<commit_message>
feat: adiciona modulo de cobertura de testes e materiais das aulas 09/10
- cobertura-garapuvu: exercicios de cobertura vs teste de mutacao
  (Jest + Stryker), com versoes "ilusao", "realidade" e "robustez"
  e as correcoes em src/corrigido
- slides das aulas 09 (Pratica de Cobertura) e 10 (Scrum e Kanban)
- artigo-ia-garapuvu.pdf e painel-metas-garapuvu.html no Modulo 3

Co-Authored-By: Claude Opus 5 (1M context) <noreply@anthropic.com>
</commit_message>
<xml_diff>
--- a/Modulo 1 - Fundamentos CTFL/Aula10_Scrum_e_Kanban.pptx
+++ b/Modulo 1 - Fundamentos CTFL/Aula10_Scrum_e_Kanban.pptx
@@ -12,6 +12,8 @@
     <p:sldId id="260" r:id="rId6"/>
     <p:sldId id="261" r:id="rId7"/>
     <p:sldId id="262" r:id="rId8"/>
+    <p:sldId id="266" r:id="rId17"/>
+    <p:sldId id="267" r:id="rId18"/>
     <p:sldId id="263" r:id="rId9"/>
     <p:sldId id="264" r:id="rId10"/>
     <p:sldId id="265" r:id="rId11"/>
@@ -2570,6 +2572,206 @@
                 <a:ea typeface="Calibri" pitchFamily="34" charset="-122"/>
                 <a:cs typeface="Calibri" pitchFamily="34" charset="-120"/>
               </a:rPr>
+              <a:t>Croft, J.</a:t>
+            </a:r>
+            <a:pPr indent="0" marL="0">
+              <a:buNone/>
+            </a:pPr>
+            <a:r>
+              <a:rPr lang="en-US" sz="1300" dirty="0">
+                <a:solidFill>
+                  <a:srgbClr val="55695C"/>
+                </a:solidFill>
+                <a:latin typeface="Calibri" pitchFamily="34" charset="0"/>
+                <a:ea typeface="Calibri" pitchFamily="34" charset="-122"/>
+                <a:cs typeface="Calibri" pitchFamily="34" charset="-120"/>
+              </a:rPr>
+              <a:t>  Dragon Dreaming — dragondreaming.org (método de desenho de projetos).</a:t>
+            </a:r>
+            <a:endParaRPr lang="en-US" sz="1300" dirty="0"/>
+          </a:p>
+        </p:txBody>
+      </p:sp>
+      <p:sp>
+        <p:nvSpPr>
+          <p:cNvPr id="417" name="Shape 414"/>
+          <p:cNvSpPr/>
+          <p:nvPr/>
+        </p:nvSpPr>
+        <p:spPr>
+          <a:xfrm>
+            <a:off x="502920" y="4846320"/>
+            <a:ext cx="11155680" cy="548640"/>
+          </a:xfrm>
+          <a:prstGeom prst="roundRect">
+            <a:avLst>
+              <a:gd name="adj" fmla="val 16667"/>
+            </a:avLst>
+          </a:prstGeom>
+          <a:solidFill>
+            <a:srgbClr val="F1F8E9"/>
+          </a:solidFill>
+          <a:ln w="12700">
+            <a:solidFill>
+              <a:srgbClr val="D7E8C8"/>
+            </a:solidFill>
+            <a:prstDash val="solid"/>
+          </a:ln>
+        </p:spPr>
+      </p:sp>
+      <p:sp>
+        <p:nvSpPr>
+          <p:cNvPr id="418" name="Shape 415"/>
+          <p:cNvSpPr/>
+          <p:nvPr/>
+        </p:nvSpPr>
+        <p:spPr>
+          <a:xfrm>
+            <a:off x="502920" y="4846320"/>
+            <a:ext cx="82296" cy="548640"/>
+          </a:xfrm>
+          <a:prstGeom prst="rect">
+            <a:avLst/>
+          </a:prstGeom>
+          <a:solidFill>
+            <a:srgbClr val="2E7D32"/>
+          </a:solidFill>
+          <a:ln/>
+        </p:spPr>
+      </p:sp>
+      <p:sp>
+        <p:nvSpPr>
+          <p:cNvPr id="419" name="Text 416"/>
+          <p:cNvSpPr/>
+          <p:nvPr/>
+        </p:nvSpPr>
+        <p:spPr>
+          <a:xfrm>
+            <a:off x="731520" y="4864608"/>
+            <a:ext cx="10789920" cy="548640"/>
+          </a:xfrm>
+          <a:prstGeom prst="rect">
+            <a:avLst/>
+          </a:prstGeom>
+          <a:noFill/>
+          <a:ln/>
+        </p:spPr>
+        <p:txBody>
+          <a:bodyPr wrap="square" lIns="50800" tIns="50800" rIns="50800" bIns="50800" rtlCol="0" anchor="ctr"/>
+          <a:lstStyle/>
+          <a:p>
+            <a:pPr indent="0" marL="0">
+              <a:buNone/>
+            </a:pPr>
+            <a:r>
+              <a:rPr lang="en-US" sz="1300" b="1" dirty="0">
+                <a:solidFill>
+                  <a:srgbClr val="14401A"/>
+                </a:solidFill>
+                <a:latin typeface="Calibri" pitchFamily="34" charset="0"/>
+                <a:ea typeface="Calibri" pitchFamily="34" charset="-122"/>
+                <a:cs typeface="Calibri" pitchFamily="34" charset="-120"/>
+              </a:rPr>
+              <a:t>Imai, M.</a:t>
+            </a:r>
+            <a:pPr indent="0" marL="0">
+              <a:buNone/>
+            </a:pPr>
+            <a:r>
+              <a:rPr lang="en-US" sz="1300" dirty="0">
+                <a:solidFill>
+                  <a:srgbClr val="55695C"/>
+                </a:solidFill>
+                <a:latin typeface="Calibri" pitchFamily="34" charset="0"/>
+                <a:ea typeface="Calibri" pitchFamily="34" charset="-122"/>
+                <a:cs typeface="Calibri" pitchFamily="34" charset="-120"/>
+              </a:rPr>
+              <a:t>  Kaizen: The Key to Japan's Competitive Success (1986).</a:t>
+            </a:r>
+            <a:endParaRPr lang="en-US" sz="1300" dirty="0"/>
+          </a:p>
+        </p:txBody>
+      </p:sp>
+      <p:sp>
+        <p:nvSpPr>
+          <p:cNvPr id="917" name="Shape 914"/>
+          <p:cNvSpPr/>
+          <p:nvPr/>
+        </p:nvSpPr>
+        <p:spPr>
+          <a:xfrm>
+            <a:off x="502920" y="5541264"/>
+            <a:ext cx="11155680" cy="548640"/>
+          </a:xfrm>
+          <a:prstGeom prst="roundRect">
+            <a:avLst>
+              <a:gd name="adj" fmla="val 16667"/>
+            </a:avLst>
+          </a:prstGeom>
+          <a:solidFill>
+            <a:srgbClr val="F1F8E9"/>
+          </a:solidFill>
+          <a:ln w="12700">
+            <a:solidFill>
+              <a:srgbClr val="D7E8C8"/>
+            </a:solidFill>
+            <a:prstDash val="solid"/>
+          </a:ln>
+        </p:spPr>
+      </p:sp>
+      <p:sp>
+        <p:nvSpPr>
+          <p:cNvPr id="918" name="Shape 915"/>
+          <p:cNvSpPr/>
+          <p:nvPr/>
+        </p:nvSpPr>
+        <p:spPr>
+          <a:xfrm>
+            <a:off x="502920" y="5541264"/>
+            <a:ext cx="82296" cy="548640"/>
+          </a:xfrm>
+          <a:prstGeom prst="rect">
+            <a:avLst/>
+          </a:prstGeom>
+          <a:solidFill>
+            <a:srgbClr val="2E7D32"/>
+          </a:solidFill>
+          <a:ln/>
+        </p:spPr>
+      </p:sp>
+      <p:sp>
+        <p:nvSpPr>
+          <p:cNvPr id="919" name="Text 916"/>
+          <p:cNvSpPr/>
+          <p:nvPr/>
+        </p:nvSpPr>
+        <p:spPr>
+          <a:xfrm>
+            <a:off x="731520" y="5559552"/>
+            <a:ext cx="10789920" cy="548640"/>
+          </a:xfrm>
+          <a:prstGeom prst="rect">
+            <a:avLst/>
+          </a:prstGeom>
+          <a:noFill/>
+          <a:ln/>
+        </p:spPr>
+        <p:txBody>
+          <a:bodyPr wrap="square" lIns="50800" tIns="50800" rIns="50800" bIns="50800" rtlCol="0" anchor="ctr"/>
+          <a:lstStyle/>
+          <a:p>
+            <a:pPr indent="0" marL="0">
+              <a:buNone/>
+            </a:pPr>
+            <a:r>
+              <a:rPr lang="en-US" sz="1300" b="1" dirty="0">
+                <a:solidFill>
+                  <a:srgbClr val="14401A"/>
+                </a:solidFill>
+                <a:latin typeface="Calibri" pitchFamily="34" charset="0"/>
+                <a:ea typeface="Calibri" pitchFamily="34" charset="-122"/>
+                <a:cs typeface="Calibri" pitchFamily="34" charset="-120"/>
+              </a:rPr>
               <a:t>Para praticar:</a:t>
             </a:r>
             <a:pPr indent="0" marL="0">
@@ -2644,6 +2846,1872 @@
                 <a:cs typeface="Calibri" pitchFamily="34" charset="-120"/>
               </a:rPr>
               <a:t>Projeto Social Garapuvu 2026 · Módulo 1 · Aula 10 — Scrum e Kanban</a:t>
+            </a:r>
+            <a:endParaRPr lang="en-US" sz="900" dirty="0"/>
+          </a:p>
+        </p:txBody>
+      </p:sp>
+    </p:spTree>
+  </p:cSld>
+  <p:clrMapOvr>
+    <a:masterClrMapping/>
+  </p:clrMapOvr>
+</p:sld>
+</file>
+
+<file path=ppt/slides/slide11.xml><?xml version="1.0" encoding="utf-8"?>
+<p:sld xmlns:a="http://schemas.openxmlformats.org/drawingml/2006/main" xmlns:r="http://schemas.openxmlformats.org/officeDocument/2006/relationships" xmlns:p="http://schemas.openxmlformats.org/presentationml/2006/main">
+  <p:cSld name="Slide 6">
+    <p:bg>
+      <p:bgPr>
+        <a:solidFill>
+          <a:srgbClr val="FFFFFF"/>
+        </a:solidFill>
+      </p:bgPr>
+    </p:bg>
+    <p:spTree>
+      <p:nvGrpSpPr>
+        <p:cNvPr id="1" name=""/>
+        <p:cNvGrpSpPr/>
+        <p:nvPr/>
+      </p:nvGrpSpPr>
+      <p:grpSpPr>
+        <a:xfrm>
+          <a:off x="0" y="0"/>
+          <a:ext cx="0" cy="0"/>
+          <a:chOff x="0" y="0"/>
+          <a:chExt cx="0" cy="0"/>
+        </a:xfrm>
+      </p:grpSpPr>
+      <p:sp>
+        <p:nvSpPr>
+          <p:cNvPr id="2" name="Text 0"/>
+          <p:cNvSpPr/>
+          <p:nvPr/>
+        </p:nvSpPr>
+        <p:spPr>
+          <a:xfrm>
+            <a:off x="502920" y="384048"/>
+            <a:ext cx="11155680" cy="777240"/>
+          </a:xfrm>
+          <a:prstGeom prst="rect">
+            <a:avLst/>
+          </a:prstGeom>
+          <a:noFill/>
+          <a:ln/>
+        </p:spPr>
+        <p:txBody>
+          <a:bodyPr wrap="square" lIns="0" tIns="0" rIns="0" bIns="0" rtlCol="0" anchor="ctr"/>
+          <a:lstStyle/>
+          <a:p>
+            <a:pPr indent="0" marL="0">
+              <a:buNone/>
+            </a:pPr>
+            <a:r>
+              <a:rPr lang="en-US" sz="3000" b="1" dirty="0">
+                <a:solidFill>
+                  <a:srgbClr val="14401A"/>
+                </a:solidFill>
+                <a:latin typeface="Trebuchet MS" pitchFamily="34" charset="0"/>
+                <a:ea typeface="Trebuchet MS" pitchFamily="34" charset="-122"/>
+                <a:cs typeface="Trebuchet MS" pitchFamily="34" charset="-120"/>
+              </a:rPr>
+              <a:t>Kaizen e Dragon Dreaming</a:t>
+            </a:r>
+            <a:endParaRPr lang="en-US" sz="3000" dirty="0"/>
+          </a:p>
+        </p:txBody>
+      </p:sp>
+      <p:sp>
+        <p:nvSpPr>
+          <p:cNvPr id="3" name="Text 1"/>
+          <p:cNvSpPr/>
+          <p:nvPr/>
+        </p:nvSpPr>
+        <p:spPr>
+          <a:xfrm>
+            <a:off x="521208" y="146304"/>
+            <a:ext cx="10972800" cy="274320"/>
+          </a:xfrm>
+          <a:prstGeom prst="rect">
+            <a:avLst/>
+          </a:prstGeom>
+          <a:noFill/>
+          <a:ln/>
+        </p:spPr>
+        <p:txBody>
+          <a:bodyPr wrap="square" lIns="0" tIns="0" rIns="0" bIns="0" rtlCol="0" anchor="ctr"/>
+          <a:lstStyle/>
+          <a:p>
+            <a:pPr indent="0" marL="0">
+              <a:buNone/>
+            </a:pPr>
+            <a:r>
+              <a:rPr lang="en-US" sz="1200" b="1" spc="200" kern="0" dirty="0">
+                <a:solidFill>
+                  <a:srgbClr val="F9A825"/>
+                </a:solidFill>
+                <a:latin typeface="Trebuchet MS" pitchFamily="34" charset="0"/>
+                <a:ea typeface="Trebuchet MS" pitchFamily="34" charset="-122"/>
+                <a:cs typeface="Trebuchet MS" pitchFamily="34" charset="-120"/>
+              </a:rPr>
+              <a:t>MELHORIA CONTÍNUA E CICLO DO PROJETO</a:t>
+            </a:r>
+            <a:endParaRPr lang="en-US" sz="1200" dirty="0"/>
+          </a:p>
+        </p:txBody>
+      </p:sp>
+      <p:sp>
+        <p:nvSpPr>
+          <p:cNvPr id="4" name="Shape 2"/>
+          <p:cNvSpPr/>
+          <p:nvPr/>
+        </p:nvSpPr>
+        <p:spPr>
+          <a:xfrm>
+            <a:off x="548640" y="1463040"/>
+            <a:ext cx="5440680" cy="3657600"/>
+          </a:xfrm>
+          <a:prstGeom prst="roundRect">
+            <a:avLst>
+              <a:gd name="adj" fmla="val 2500"/>
+            </a:avLst>
+          </a:prstGeom>
+          <a:solidFill>
+            <a:srgbClr val="F1F8E9"/>
+          </a:solidFill>
+          <a:ln w="12700">
+            <a:solidFill>
+              <a:srgbClr val="7CB342"/>
+            </a:solidFill>
+            <a:prstDash val="solid"/>
+          </a:ln>
+        </p:spPr>
+      </p:sp>
+      <p:sp>
+        <p:nvSpPr>
+          <p:cNvPr id="5" name="Shape 3"/>
+          <p:cNvSpPr/>
+          <p:nvPr/>
+        </p:nvSpPr>
+        <p:spPr>
+          <a:xfrm>
+            <a:off x="822960" y="1737360"/>
+            <a:ext cx="731520" cy="731520"/>
+          </a:xfrm>
+          <a:prstGeom prst="ellipse">
+            <a:avLst/>
+          </a:prstGeom>
+          <a:solidFill>
+            <a:srgbClr val="2E7D32"/>
+          </a:solidFill>
+          <a:ln/>
+        </p:spPr>
+      </p:sp>
+      <p:pic>
+        <p:nvPicPr>
+          <p:cNvPr id="6" name="Image 0" descr="preencoded.png">    </p:cNvPr>
+          <p:cNvPicPr>
+            <a:picLocks noChangeAspect="1"/>
+          </p:cNvPicPr>
+          <p:nvPr/>
+        </p:nvPicPr>
+        <p:blipFill>
+          <a:blip r:embed="rId1"/>
+          <a:stretch>
+            <a:fillRect/>
+          </a:stretch>
+        </p:blipFill>
+        <p:spPr>
+          <a:xfrm>
+            <a:off x="998525" y="1912925"/>
+            <a:ext cx="380390" cy="380390"/>
+          </a:xfrm>
+          <a:prstGeom prst="rect">
+            <a:avLst/>
+          </a:prstGeom>
+        </p:spPr>
+      </p:pic>
+      <p:sp>
+        <p:nvSpPr>
+          <p:cNvPr id="7" name="Text 4"/>
+          <p:cNvSpPr/>
+          <p:nvPr/>
+        </p:nvSpPr>
+        <p:spPr>
+          <a:xfrm>
+            <a:off x="1691640" y="1783080"/>
+            <a:ext cx="4114800" cy="640080"/>
+          </a:xfrm>
+          <a:prstGeom prst="rect">
+            <a:avLst/>
+          </a:prstGeom>
+          <a:noFill/>
+          <a:ln/>
+        </p:spPr>
+        <p:txBody>
+          <a:bodyPr wrap="square" lIns="0" tIns="0" rIns="0" bIns="0" rtlCol="0" anchor="ctr"/>
+          <a:lstStyle/>
+          <a:p>
+            <a:pPr indent="0" marL="0">
+              <a:buNone/>
+            </a:pPr>
+            <a:r>
+              <a:rPr lang="en-US" sz="1800" b="1" dirty="0">
+                <a:solidFill>
+                  <a:srgbClr val="2E7D32"/>
+                </a:solidFill>
+                <a:latin typeface="Trebuchet MS" pitchFamily="34" charset="0"/>
+                <a:ea typeface="Trebuchet MS" pitchFamily="34" charset="-122"/>
+                <a:cs typeface="Trebuchet MS" pitchFamily="34" charset="-120"/>
+              </a:rPr>
+              <a:t>Kaizen (改善)</a:t>
+            </a:r>
+            <a:endParaRPr lang="en-US" sz="1800" dirty="0"/>
+          </a:p>
+        </p:txBody>
+      </p:sp>
+      <p:sp>
+        <p:nvSpPr>
+          <p:cNvPr id="8" name="Text 5"/>
+          <p:cNvSpPr/>
+          <p:nvPr/>
+        </p:nvSpPr>
+        <p:spPr>
+          <a:xfrm>
+            <a:off x="868680" y="2606040"/>
+            <a:ext cx="4846320" cy="2377440"/>
+          </a:xfrm>
+          <a:prstGeom prst="rect">
+            <a:avLst/>
+          </a:prstGeom>
+          <a:noFill/>
+          <a:ln/>
+        </p:spPr>
+        <p:txBody>
+          <a:bodyPr wrap="square" lIns="0" tIns="0" rIns="0" bIns="0" rtlCol="0" anchor="t"/>
+          <a:lstStyle/>
+          <a:p>
+            <a:pPr marL="342900" indent="-342900">
+              <a:spcAft>
+                <a:spcPts val="900"/>
+              </a:spcAft>
+              <a:buSzPct val="100000"/>
+              <a:buChar char="•"/>
+            </a:pPr>
+            <a:r>
+              <a:rPr lang="en-US" sz="1350" dirty="0">
+                <a:solidFill>
+                  <a:srgbClr val="1B3A1B"/>
+                </a:solidFill>
+                <a:latin typeface="Calibri" pitchFamily="34" charset="0"/>
+                <a:ea typeface="Calibri" pitchFamily="34" charset="-122"/>
+                <a:cs typeface="Calibri" pitchFamily="34" charset="-120"/>
+              </a:rPr>
+              <a:t>Do japonês kai (mudança) + zen (bom): mudança para melhor.</a:t>
+            </a:r>
+            <a:endParaRPr lang="en-US" sz="1350" dirty="0"/>
+          </a:p>
+          <a:p>
+            <a:pPr marL="342900" indent="-342900">
+              <a:spcAft>
+                <a:spcPts val="900"/>
+              </a:spcAft>
+              <a:buSzPct val="100000"/>
+              <a:buChar char="•"/>
+            </a:pPr>
+            <a:r>
+              <a:rPr lang="en-US" sz="1350" dirty="0">
+                <a:solidFill>
+                  <a:srgbClr val="1B3A1B"/>
+                </a:solidFill>
+                <a:latin typeface="Calibri" pitchFamily="34" charset="0"/>
+                <a:ea typeface="Calibri" pitchFamily="34" charset="-122"/>
+                <a:cs typeface="Calibri" pitchFamily="34" charset="-120"/>
+              </a:rPr>
+              <a:t>Nasceu no Japão do pós-guerra e ficou famoso no Sistema Toyota de Produção.</a:t>
+            </a:r>
+            <a:endParaRPr lang="en-US" sz="1350" dirty="0"/>
+          </a:p>
+          <a:p>
+            <a:pPr marL="342900" indent="-342900">
+              <a:spcAft>
+                <a:spcPts val="900"/>
+              </a:spcAft>
+              <a:buSzPct val="100000"/>
+              <a:buChar char="•"/>
+            </a:pPr>
+            <a:r>
+              <a:rPr lang="en-US" sz="1350" dirty="0">
+                <a:solidFill>
+                  <a:srgbClr val="1B3A1B"/>
+                </a:solidFill>
+                <a:latin typeface="Calibri" pitchFamily="34" charset="0"/>
+                <a:ea typeface="Calibri" pitchFamily="34" charset="-122"/>
+                <a:cs typeface="Calibri" pitchFamily="34" charset="-120"/>
+              </a:rPr>
+              <a:t>Muitas melhorias pequenas e constantes valem mais que uma grande reforma — e quem propõe é quem faz o trabalho.</a:t>
+            </a:r>
+            <a:endParaRPr lang="en-US" sz="1350" dirty="0"/>
+          </a:p>
+          <a:p>
+            <a:pPr marL="342900" indent="-342900">
+              <a:spcAft>
+                <a:spcPts val="900"/>
+              </a:spcAft>
+              <a:buSzPct val="100000"/>
+              <a:buChar char="•"/>
+            </a:pPr>
+            <a:r>
+              <a:rPr lang="en-US" sz="1350" dirty="0">
+                <a:solidFill>
+                  <a:srgbClr val="1B3A1B"/>
+                </a:solidFill>
+                <a:latin typeface="Calibri" pitchFamily="34" charset="0"/>
+                <a:ea typeface="Calibri" pitchFamily="34" charset="-122"/>
+                <a:cs typeface="Calibri" pitchFamily="34" charset="-120"/>
+              </a:rPr>
+              <a:t>Roda no ciclo PDCA: Planejar → Fazer → Checar → Agir.</a:t>
+            </a:r>
+            <a:endParaRPr lang="en-US" sz="1350" dirty="0"/>
+          </a:p>
+        </p:txBody>
+      </p:sp>
+      <p:sp>
+        <p:nvSpPr>
+          <p:cNvPr id="9" name="Shape 6"/>
+          <p:cNvSpPr/>
+          <p:nvPr/>
+        </p:nvSpPr>
+        <p:spPr>
+          <a:xfrm>
+            <a:off x="6309360" y="1463040"/>
+            <a:ext cx="5440680" cy="3657600"/>
+          </a:xfrm>
+          <a:prstGeom prst="roundRect">
+            <a:avLst>
+              <a:gd name="adj" fmla="val 2500"/>
+            </a:avLst>
+          </a:prstGeom>
+          <a:solidFill>
+            <a:srgbClr val="FFF3CC"/>
+          </a:solidFill>
+          <a:ln w="12700">
+            <a:solidFill>
+              <a:srgbClr val="F9A825"/>
+            </a:solidFill>
+            <a:prstDash val="solid"/>
+          </a:ln>
+        </p:spPr>
+      </p:sp>
+      <p:sp>
+        <p:nvSpPr>
+          <p:cNvPr id="10" name="Shape 7"/>
+          <p:cNvSpPr/>
+          <p:nvPr/>
+        </p:nvSpPr>
+        <p:spPr>
+          <a:xfrm>
+            <a:off x="6583680" y="1737360"/>
+            <a:ext cx="731520" cy="731520"/>
+          </a:xfrm>
+          <a:prstGeom prst="ellipse">
+            <a:avLst/>
+          </a:prstGeom>
+          <a:solidFill>
+            <a:srgbClr val="F9A825"/>
+          </a:solidFill>
+          <a:ln/>
+        </p:spPr>
+      </p:sp>
+      <p:pic>
+        <p:nvPicPr>
+          <p:cNvPr id="11" name="Image 1" descr="preencoded.png">    </p:cNvPr>
+          <p:cNvPicPr>
+            <a:picLocks noChangeAspect="1"/>
+          </p:cNvPicPr>
+          <p:nvPr/>
+        </p:nvPicPr>
+        <p:blipFill>
+          <a:blip r:embed="rId2"/>
+          <a:stretch>
+            <a:fillRect/>
+          </a:stretch>
+        </p:blipFill>
+        <p:spPr>
+          <a:xfrm>
+            <a:off x="6759245" y="1912925"/>
+            <a:ext cx="380390" cy="380390"/>
+          </a:xfrm>
+          <a:prstGeom prst="rect">
+            <a:avLst/>
+          </a:prstGeom>
+        </p:spPr>
+      </p:pic>
+      <p:sp>
+        <p:nvSpPr>
+          <p:cNvPr id="12" name="Text 8"/>
+          <p:cNvSpPr/>
+          <p:nvPr/>
+        </p:nvSpPr>
+        <p:spPr>
+          <a:xfrm>
+            <a:off x="7452360" y="1783080"/>
+            <a:ext cx="4114800" cy="640080"/>
+          </a:xfrm>
+          <a:prstGeom prst="rect">
+            <a:avLst/>
+          </a:prstGeom>
+          <a:noFill/>
+          <a:ln/>
+        </p:spPr>
+        <p:txBody>
+          <a:bodyPr wrap="square" lIns="0" tIns="0" rIns="0" bIns="0" rtlCol="0" anchor="ctr"/>
+          <a:lstStyle/>
+          <a:p>
+            <a:pPr indent="0" marL="0">
+              <a:buNone/>
+            </a:pPr>
+            <a:r>
+              <a:rPr lang="en-US" sz="1800" b="1" dirty="0">
+                <a:solidFill>
+                  <a:srgbClr val="7A5200"/>
+                </a:solidFill>
+                <a:latin typeface="Trebuchet MS" pitchFamily="34" charset="0"/>
+                <a:ea typeface="Trebuchet MS" pitchFamily="34" charset="-122"/>
+                <a:cs typeface="Trebuchet MS" pitchFamily="34" charset="-120"/>
+              </a:rPr>
+              <a:t>Dragon Dreaming</a:t>
+            </a:r>
+            <a:endParaRPr lang="en-US" sz="1800" dirty="0"/>
+          </a:p>
+        </p:txBody>
+      </p:sp>
+      <p:sp>
+        <p:nvSpPr>
+          <p:cNvPr id="13" name="Text 9"/>
+          <p:cNvSpPr/>
+          <p:nvPr/>
+        </p:nvSpPr>
+        <p:spPr>
+          <a:xfrm>
+            <a:off x="6629400" y="2606040"/>
+            <a:ext cx="4846320" cy="2377440"/>
+          </a:xfrm>
+          <a:prstGeom prst="rect">
+            <a:avLst/>
+          </a:prstGeom>
+          <a:noFill/>
+          <a:ln/>
+        </p:spPr>
+        <p:txBody>
+          <a:bodyPr wrap="square" lIns="0" tIns="0" rIns="0" bIns="0" rtlCol="0" anchor="t"/>
+          <a:lstStyle/>
+          <a:p>
+            <a:pPr marL="342900" indent="-342900">
+              <a:spcAft>
+                <a:spcPts val="900"/>
+              </a:spcAft>
+              <a:buSzPct val="100000"/>
+              <a:buChar char="•"/>
+            </a:pPr>
+            <a:r>
+              <a:rPr lang="en-US" sz="1350" dirty="0">
+                <a:solidFill>
+                  <a:srgbClr val="5A4500"/>
+                </a:solidFill>
+                <a:latin typeface="Calibri" pitchFamily="34" charset="0"/>
+                <a:ea typeface="Calibri" pitchFamily="34" charset="-122"/>
+                <a:cs typeface="Calibri" pitchFamily="34" charset="-120"/>
+              </a:rPr>
+              <a:t>Desenho de projetos de John Croft e Vivienne Elanta, na Austrália Ocidental (desde os anos 1980).</a:t>
+            </a:r>
+            <a:endParaRPr lang="en-US" sz="1350" dirty="0"/>
+          </a:p>
+          <a:p>
+            <a:pPr marL="342900" indent="-342900">
+              <a:spcAft>
+                <a:spcPts val="900"/>
+              </a:spcAft>
+              <a:buSzPct val="100000"/>
+              <a:buChar char="•"/>
+            </a:pPr>
+            <a:r>
+              <a:rPr lang="en-US" sz="1350" dirty="0">
+                <a:solidFill>
+                  <a:srgbClr val="5A4500"/>
+                </a:solidFill>
+                <a:latin typeface="Calibri" pitchFamily="34" charset="0"/>
+                <a:ea typeface="Calibri" pitchFamily="34" charset="-122"/>
+                <a:cs typeface="Calibri" pitchFamily="34" charset="-120"/>
+              </a:rPr>
+              <a:t>Quatro fases em roda: Sonhar → Planejar → Realizar → Celebrar.</a:t>
+            </a:r>
+            <a:endParaRPr lang="en-US" sz="1350" dirty="0"/>
+          </a:p>
+          <a:p>
+            <a:pPr marL="342900" indent="-342900">
+              <a:spcAft>
+                <a:spcPts val="900"/>
+              </a:spcAft>
+              <a:buSzPct val="100000"/>
+              <a:buChar char="•"/>
+            </a:pPr>
+            <a:r>
+              <a:rPr lang="en-US" sz="1350" dirty="0">
+                <a:solidFill>
+                  <a:srgbClr val="5A4500"/>
+                </a:solidFill>
+                <a:latin typeface="Calibri" pitchFamily="34" charset="0"/>
+                <a:ea typeface="Calibri" pitchFamily="34" charset="-122"/>
+                <a:cs typeface="Calibri" pitchFamily="34" charset="-120"/>
+              </a:rPr>
+              <a:t>Começa pelo Círculo de Sonhos: todo mundo fala antes de qualquer decisão.</a:t>
+            </a:r>
+            <a:endParaRPr lang="en-US" sz="1350" dirty="0"/>
+          </a:p>
+          <a:p>
+            <a:pPr marL="342900" indent="-342900">
+              <a:spcAft>
+                <a:spcPts val="900"/>
+              </a:spcAft>
+              <a:buSzPct val="100000"/>
+              <a:buChar char="•"/>
+            </a:pPr>
+            <a:r>
+              <a:rPr lang="en-US" sz="1350" dirty="0">
+                <a:solidFill>
+                  <a:srgbClr val="5A4500"/>
+                </a:solidFill>
+                <a:latin typeface="Calibri" pitchFamily="34" charset="0"/>
+                <a:ea typeface="Calibri" pitchFamily="34" charset="-122"/>
+                <a:cs typeface="Calibri" pitchFamily="34" charset="-120"/>
+              </a:rPr>
+              <a:t>Para Croft, a fase mais pulada é Celebrar — e é ela que segura as pessoas no projeto.</a:t>
+            </a:r>
+            <a:endParaRPr lang="en-US" sz="1350" dirty="0"/>
+          </a:p>
+        </p:txBody>
+      </p:sp>
+      <p:sp>
+        <p:nvSpPr>
+          <p:cNvPr id="14" name="Shape 10"/>
+          <p:cNvSpPr/>
+          <p:nvPr/>
+        </p:nvSpPr>
+        <p:spPr>
+          <a:xfrm>
+            <a:off x="548640" y="5257800"/>
+            <a:ext cx="11109960" cy="731520"/>
+          </a:xfrm>
+          <a:prstGeom prst="roundRect">
+            <a:avLst>
+              <a:gd name="adj" fmla="val 12500"/>
+            </a:avLst>
+          </a:prstGeom>
+          <a:solidFill>
+            <a:srgbClr val="F1F8E9"/>
+          </a:solidFill>
+          <a:ln w="12700">
+            <a:solidFill>
+              <a:srgbClr val="7CB342"/>
+            </a:solidFill>
+            <a:prstDash val="solid"/>
+          </a:ln>
+        </p:spPr>
+      </p:sp>
+      <p:sp>
+        <p:nvSpPr>
+          <p:cNvPr id="15" name="Shape 11"/>
+          <p:cNvSpPr/>
+          <p:nvPr/>
+        </p:nvSpPr>
+        <p:spPr>
+          <a:xfrm>
+            <a:off x="777240" y="5340096"/>
+            <a:ext cx="566928" cy="566928"/>
+          </a:xfrm>
+          <a:prstGeom prst="ellipse">
+            <a:avLst/>
+          </a:prstGeom>
+          <a:solidFill>
+            <a:srgbClr val="F9A825"/>
+          </a:solidFill>
+          <a:ln/>
+        </p:spPr>
+      </p:sp>
+      <p:pic>
+        <p:nvPicPr>
+          <p:cNvPr id="16" name="Image 2" descr="preencoded.png">    </p:cNvPr>
+          <p:cNvPicPr>
+            <a:picLocks noChangeAspect="1"/>
+          </p:cNvPicPr>
+          <p:nvPr/>
+        </p:nvPicPr>
+        <p:blipFill>
+          <a:blip r:embed="rId3"/>
+          <a:stretch>
+            <a:fillRect/>
+          </a:stretch>
+        </p:blipFill>
+        <p:spPr>
+          <a:xfrm>
+            <a:off x="913303" y="5476159"/>
+            <a:ext cx="294803" cy="294803"/>
+          </a:xfrm>
+          <a:prstGeom prst="rect">
+            <a:avLst/>
+          </a:prstGeom>
+        </p:spPr>
+      </p:pic>
+      <p:sp>
+        <p:nvSpPr>
+          <p:cNvPr id="17" name="Text 12"/>
+          <p:cNvSpPr/>
+          <p:nvPr/>
+        </p:nvSpPr>
+        <p:spPr>
+          <a:xfrm>
+            <a:off x="1508760" y="5349240"/>
+            <a:ext cx="9921240" cy="548640"/>
+          </a:xfrm>
+          <a:prstGeom prst="rect">
+            <a:avLst/>
+          </a:prstGeom>
+          <a:noFill/>
+          <a:ln/>
+        </p:spPr>
+        <p:txBody>
+          <a:bodyPr wrap="square" lIns="0" tIns="0" rIns="0" bIns="0" rtlCol="0" anchor="ctr"/>
+          <a:lstStyle/>
+          <a:p>
+            <a:pPr indent="0" marL="0">
+              <a:buNone/>
+            </a:pPr>
+            <a:r>
+              <a:rPr lang="en-US" sz="1350" b="1" dirty="0">
+                <a:solidFill>
+                  <a:srgbClr val="2E7D32"/>
+                </a:solidFill>
+                <a:latin typeface="Calibri" pitchFamily="34" charset="0"/>
+                <a:ea typeface="Calibri" pitchFamily="34" charset="-122"/>
+                <a:cs typeface="Calibri" pitchFamily="34" charset="-120"/>
+              </a:rPr>
+              <a:t>Leve daqui:  </a:t>
+            </a:r>
+            <a:pPr indent="0" marL="0">
+              <a:buNone/>
+            </a:pPr>
+            <a:r>
+              <a:rPr lang="en-US" sz="1350" dirty="0">
+                <a:solidFill>
+                  <a:srgbClr val="1B3A1B"/>
+                </a:solidFill>
+                <a:latin typeface="Calibri" pitchFamily="34" charset="0"/>
+                <a:ea typeface="Calibri" pitchFamily="34" charset="-122"/>
+                <a:cs typeface="Calibri" pitchFamily="34" charset="-120"/>
+              </a:rPr>
+              <a:t>Kaizen melhora COMO o time trabalha; Dragon Dreaming cuida do PORQUÊ e de quem trabalha.</a:t>
+            </a:r>
+            <a:endParaRPr lang="en-US" sz="1350" dirty="0"/>
+          </a:p>
+        </p:txBody>
+      </p:sp>
+      <p:sp>
+        <p:nvSpPr>
+          <p:cNvPr id="18" name="Shape 13"/>
+          <p:cNvSpPr/>
+          <p:nvPr/>
+        </p:nvSpPr>
+        <p:spPr>
+          <a:xfrm>
+            <a:off x="0" y="6565392"/>
+            <a:ext cx="12188952" cy="292608"/>
+          </a:xfrm>
+          <a:prstGeom prst="rect">
+            <a:avLst/>
+          </a:prstGeom>
+          <a:solidFill>
+            <a:srgbClr val="14401A"/>
+          </a:solidFill>
+          <a:ln/>
+        </p:spPr>
+      </p:sp>
+      <p:sp>
+        <p:nvSpPr>
+          <p:cNvPr id="19" name="Text 14"/>
+          <p:cNvSpPr/>
+          <p:nvPr/>
+        </p:nvSpPr>
+        <p:spPr>
+          <a:xfrm>
+            <a:off x="365760" y="6565392"/>
+            <a:ext cx="8229600" cy="292608"/>
+          </a:xfrm>
+          <a:prstGeom prst="rect">
+            <a:avLst/>
+          </a:prstGeom>
+          <a:noFill/>
+          <a:ln/>
+        </p:spPr>
+        <p:txBody>
+          <a:bodyPr wrap="square" lIns="0" tIns="0" rIns="0" bIns="0" rtlCol="0" anchor="ctr"/>
+          <a:lstStyle/>
+          <a:p>
+            <a:pPr algn="l" indent="0" marL="0">
+              <a:buNone/>
+            </a:pPr>
+            <a:r>
+              <a:rPr lang="en-US" sz="900" dirty="0">
+                <a:solidFill>
+                  <a:srgbClr val="CFE8C4"/>
+                </a:solidFill>
+                <a:latin typeface="Calibri" pitchFamily="34" charset="0"/>
+                <a:ea typeface="Calibri" pitchFamily="34" charset="-122"/>
+                <a:cs typeface="Calibri" pitchFamily="34" charset="-120"/>
+              </a:rPr>
+              <a:t>Projeto Social Garapuvu 2026 · Módulo 1 · Aula 10 — Scrum e Kanban</a:t>
+            </a:r>
+            <a:endParaRPr lang="en-US" sz="900" dirty="0"/>
+          </a:p>
+        </p:txBody>
+      </p:sp>
+      <p:sp>
+        <p:nvSpPr>
+          <p:cNvPr id="20" name="Text 15"/>
+          <p:cNvSpPr/>
+          <p:nvPr/>
+        </p:nvSpPr>
+        <p:spPr>
+          <a:xfrm>
+            <a:off x="11338560" y="6565392"/>
+            <a:ext cx="502920" cy="292608"/>
+          </a:xfrm>
+          <a:prstGeom prst="rect">
+            <a:avLst/>
+          </a:prstGeom>
+          <a:noFill/>
+          <a:ln/>
+        </p:spPr>
+        <p:txBody>
+          <a:bodyPr wrap="square" lIns="0" tIns="0" rIns="0" bIns="0" rtlCol="0" anchor="ctr"/>
+          <a:lstStyle/>
+          <a:p>
+            <a:pPr algn="r" indent="0" marL="0">
+              <a:buNone/>
+            </a:pPr>
+            <a:r>
+              <a:rPr lang="en-US" sz="900" dirty="0">
+                <a:solidFill>
+                  <a:srgbClr val="CFE8C4"/>
+                </a:solidFill>
+                <a:latin typeface="Calibri" pitchFamily="34" charset="0"/>
+                <a:ea typeface="Calibri" pitchFamily="34" charset="-122"/>
+                <a:cs typeface="Calibri" pitchFamily="34" charset="-120"/>
+              </a:rPr>
+              <a:t>7</a:t>
+            </a:r>
+            <a:endParaRPr lang="en-US" sz="900" dirty="0"/>
+          </a:p>
+        </p:txBody>
+      </p:sp>
+    </p:spTree>
+  </p:cSld>
+  <p:clrMapOvr>
+    <a:masterClrMapping/>
+  </p:clrMapOvr>
+</p:sld>
+</file>
+
+<file path=ppt/slides/slide12.xml><?xml version="1.0" encoding="utf-8"?>
+<p:sld xmlns:a="http://schemas.openxmlformats.org/drawingml/2006/main" xmlns:r="http://schemas.openxmlformats.org/officeDocument/2006/relationships" xmlns:p="http://schemas.openxmlformats.org/presentationml/2006/main">
+  <p:cSld name="Slide 4">
+    <p:bg>
+      <p:bgPr>
+        <a:solidFill>
+          <a:srgbClr val="FFFFFF"/>
+        </a:solidFill>
+      </p:bgPr>
+    </p:bg>
+    <p:spTree>
+      <p:nvGrpSpPr>
+        <p:cNvPr id="1" name=""/>
+        <p:cNvGrpSpPr/>
+        <p:nvPr/>
+      </p:nvGrpSpPr>
+      <p:grpSpPr>
+        <a:xfrm>
+          <a:off x="0" y="0"/>
+          <a:ext cx="0" cy="0"/>
+          <a:chOff x="0" y="0"/>
+          <a:chExt cx="0" cy="0"/>
+        </a:xfrm>
+      </p:grpSpPr>
+      <p:sp>
+        <p:nvSpPr>
+          <p:cNvPr id="2" name="Text 0"/>
+          <p:cNvSpPr/>
+          <p:nvPr/>
+        </p:nvSpPr>
+        <p:spPr>
+          <a:xfrm>
+            <a:off x="502920" y="384048"/>
+            <a:ext cx="11155680" cy="777240"/>
+          </a:xfrm>
+          <a:prstGeom prst="rect">
+            <a:avLst/>
+          </a:prstGeom>
+          <a:noFill/>
+          <a:ln/>
+        </p:spPr>
+        <p:txBody>
+          <a:bodyPr wrap="square" lIns="0" tIns="0" rIns="0" bIns="0" rtlCol="0" anchor="ctr"/>
+          <a:lstStyle/>
+          <a:p>
+            <a:pPr indent="0" marL="0">
+              <a:buNone/>
+            </a:pPr>
+            <a:r>
+              <a:rPr lang="en-US" sz="3000" b="1" dirty="0">
+                <a:solidFill>
+                  <a:srgbClr val="14401A"/>
+                </a:solidFill>
+                <a:latin typeface="Trebuchet MS" pitchFamily="34" charset="0"/>
+                <a:ea typeface="Trebuchet MS" pitchFamily="34" charset="-122"/>
+                <a:cs typeface="Trebuchet MS" pitchFamily="34" charset="-120"/>
+              </a:rPr>
+              <a:t>Onde aplicar no Scrum, no Kanban e no híbrido</a:t>
+            </a:r>
+            <a:endParaRPr lang="en-US" sz="3000" dirty="0"/>
+          </a:p>
+        </p:txBody>
+      </p:sp>
+      <p:sp>
+        <p:nvSpPr>
+          <p:cNvPr id="3" name="Text 1"/>
+          <p:cNvSpPr/>
+          <p:nvPr/>
+        </p:nvSpPr>
+        <p:spPr>
+          <a:xfrm>
+            <a:off x="521208" y="146304"/>
+            <a:ext cx="10972800" cy="274320"/>
+          </a:xfrm>
+          <a:prstGeom prst="rect">
+            <a:avLst/>
+          </a:prstGeom>
+          <a:noFill/>
+          <a:ln/>
+        </p:spPr>
+        <p:txBody>
+          <a:bodyPr wrap="square" lIns="0" tIns="0" rIns="0" bIns="0" rtlCol="0" anchor="ctr"/>
+          <a:lstStyle/>
+          <a:p>
+            <a:pPr indent="0" marL="0">
+              <a:buNone/>
+            </a:pPr>
+            <a:r>
+              <a:rPr lang="en-US" sz="1200" b="1" spc="200" kern="0" dirty="0">
+                <a:solidFill>
+                  <a:srgbClr val="F9A825"/>
+                </a:solidFill>
+                <a:latin typeface="Trebuchet MS" pitchFamily="34" charset="0"/>
+                <a:ea typeface="Trebuchet MS" pitchFamily="34" charset="-122"/>
+                <a:cs typeface="Trebuchet MS" pitchFamily="34" charset="-120"/>
+              </a:rPr>
+              <a:t>NA PRÁTICA</a:t>
+            </a:r>
+            <a:endParaRPr lang="en-US" sz="1200" dirty="0"/>
+          </a:p>
+        </p:txBody>
+      </p:sp>
+      <p:sp>
+        <p:nvSpPr>
+          <p:cNvPr id="4" name="Shape 2"/>
+          <p:cNvSpPr/>
+          <p:nvPr/>
+        </p:nvSpPr>
+        <p:spPr>
+          <a:xfrm>
+            <a:off x="548640" y="1481328"/>
+            <a:ext cx="3544824" cy="2011680"/>
+          </a:xfrm>
+          <a:prstGeom prst="roundRect">
+            <a:avLst>
+              <a:gd name="adj" fmla="val 4545"/>
+            </a:avLst>
+          </a:prstGeom>
+          <a:solidFill>
+            <a:srgbClr val="FFFFFF"/>
+          </a:solidFill>
+          <a:ln w="12700">
+            <a:solidFill>
+              <a:srgbClr val="D7E8C8"/>
+            </a:solidFill>
+            <a:prstDash val="solid"/>
+          </a:ln>
+        </p:spPr>
+      </p:sp>
+      <p:sp>
+        <p:nvSpPr>
+          <p:cNvPr id="5" name="Shape 3"/>
+          <p:cNvSpPr/>
+          <p:nvPr/>
+        </p:nvSpPr>
+        <p:spPr>
+          <a:xfrm>
+            <a:off x="804672" y="1719072"/>
+            <a:ext cx="640080" cy="640080"/>
+          </a:xfrm>
+          <a:prstGeom prst="ellipse">
+            <a:avLst/>
+          </a:prstGeom>
+          <a:solidFill>
+            <a:srgbClr val="2E7D32"/>
+          </a:solidFill>
+          <a:ln/>
+        </p:spPr>
+      </p:sp>
+      <p:pic>
+        <p:nvPicPr>
+          <p:cNvPr id="6" name="Image 0" descr="preencoded.png">    </p:cNvPr>
+          <p:cNvPicPr>
+            <a:picLocks noChangeAspect="1"/>
+          </p:cNvPicPr>
+          <p:nvPr/>
+        </p:nvPicPr>
+        <p:blipFill>
+          <a:blip r:embed="rId1"/>
+          <a:stretch>
+            <a:fillRect/>
+          </a:stretch>
+        </p:blipFill>
+        <p:spPr>
+          <a:xfrm>
+            <a:off x="958291" y="1872691"/>
+            <a:ext cx="332842" cy="332842"/>
+          </a:xfrm>
+          <a:prstGeom prst="rect">
+            <a:avLst/>
+          </a:prstGeom>
+        </p:spPr>
+      </p:pic>
+      <p:sp>
+        <p:nvSpPr>
+          <p:cNvPr id="7" name="Text 4"/>
+          <p:cNvSpPr/>
+          <p:nvPr/>
+        </p:nvSpPr>
+        <p:spPr>
+          <a:xfrm>
+            <a:off x="804672" y="2441448"/>
+            <a:ext cx="3087624" cy="411480"/>
+          </a:xfrm>
+          <a:prstGeom prst="rect">
+            <a:avLst/>
+          </a:prstGeom>
+          <a:noFill/>
+          <a:ln/>
+        </p:spPr>
+        <p:txBody>
+          <a:bodyPr wrap="square" lIns="0" tIns="0" rIns="0" bIns="0" rtlCol="0" anchor="t"/>
+          <a:lstStyle/>
+          <a:p>
+            <a:pPr indent="0" marL="0">
+              <a:buNone/>
+            </a:pPr>
+            <a:r>
+              <a:rPr lang="en-US" sz="1450" b="1" dirty="0">
+                <a:solidFill>
+                  <a:srgbClr val="14401A"/>
+                </a:solidFill>
+                <a:latin typeface="Trebuchet MS" pitchFamily="34" charset="0"/>
+                <a:ea typeface="Trebuchet MS" pitchFamily="34" charset="-122"/>
+                <a:cs typeface="Trebuchet MS" pitchFamily="34" charset="-120"/>
+              </a:rPr>
+              <a:t>Scrum · Retrospectiva</a:t>
+            </a:r>
+            <a:endParaRPr lang="en-US" sz="1450" dirty="0"/>
+          </a:p>
+        </p:txBody>
+      </p:sp>
+      <p:sp>
+        <p:nvSpPr>
+          <p:cNvPr id="8" name="Text 5"/>
+          <p:cNvSpPr/>
+          <p:nvPr/>
+        </p:nvSpPr>
+        <p:spPr>
+          <a:xfrm>
+            <a:off x="804672" y="2834640"/>
+            <a:ext cx="3087624" cy="594360"/>
+          </a:xfrm>
+          <a:prstGeom prst="rect">
+            <a:avLst/>
+          </a:prstGeom>
+          <a:noFill/>
+          <a:ln/>
+        </p:spPr>
+        <p:txBody>
+          <a:bodyPr wrap="square" lIns="0" tIns="0" rIns="0" bIns="0" rtlCol="0" anchor="t"/>
+          <a:lstStyle/>
+          <a:p>
+            <a:pPr indent="0" marL="0">
+              <a:buNone/>
+            </a:pPr>
+            <a:r>
+              <a:rPr lang="en-US" sz="1200" dirty="0">
+                <a:solidFill>
+                  <a:srgbClr val="55695C"/>
+                </a:solidFill>
+                <a:latin typeface="Calibri" pitchFamily="34" charset="0"/>
+                <a:ea typeface="Calibri" pitchFamily="34" charset="-122"/>
+                <a:cs typeface="Calibri" pitchFamily="34" charset="-120"/>
+              </a:rPr>
+              <a:t>É o motor kaizen do Scrum. Saia da retro com 1 ou 2 melhorias pequenas, com dono e prazo.</a:t>
+            </a:r>
+            <a:endParaRPr lang="en-US" sz="1200" dirty="0"/>
+          </a:p>
+        </p:txBody>
+      </p:sp>
+      <p:sp>
+        <p:nvSpPr>
+          <p:cNvPr id="9" name="Shape 6"/>
+          <p:cNvSpPr/>
+          <p:nvPr/>
+        </p:nvSpPr>
+        <p:spPr>
+          <a:xfrm>
+            <a:off x="4322064" y="1481328"/>
+            <a:ext cx="3544824" cy="2011680"/>
+          </a:xfrm>
+          <a:prstGeom prst="roundRect">
+            <a:avLst>
+              <a:gd name="adj" fmla="val 4545"/>
+            </a:avLst>
+          </a:prstGeom>
+          <a:solidFill>
+            <a:srgbClr val="FFFFFF"/>
+          </a:solidFill>
+          <a:ln w="12700">
+            <a:solidFill>
+              <a:srgbClr val="D7E8C8"/>
+            </a:solidFill>
+            <a:prstDash val="solid"/>
+          </a:ln>
+        </p:spPr>
+      </p:sp>
+      <p:sp>
+        <p:nvSpPr>
+          <p:cNvPr id="10" name="Shape 7"/>
+          <p:cNvSpPr/>
+          <p:nvPr/>
+        </p:nvSpPr>
+        <p:spPr>
+          <a:xfrm>
+            <a:off x="4578096" y="1719072"/>
+            <a:ext cx="640080" cy="640080"/>
+          </a:xfrm>
+          <a:prstGeom prst="ellipse">
+            <a:avLst/>
+          </a:prstGeom>
+          <a:solidFill>
+            <a:srgbClr val="43A047"/>
+          </a:solidFill>
+          <a:ln/>
+        </p:spPr>
+      </p:sp>
+      <p:pic>
+        <p:nvPicPr>
+          <p:cNvPr id="11" name="Image 1" descr="preencoded.png">    </p:cNvPr>
+          <p:cNvPicPr>
+            <a:picLocks noChangeAspect="1"/>
+          </p:cNvPicPr>
+          <p:nvPr/>
+        </p:nvPicPr>
+        <p:blipFill>
+          <a:blip r:embed="rId2"/>
+          <a:stretch>
+            <a:fillRect/>
+          </a:stretch>
+        </p:blipFill>
+        <p:spPr>
+          <a:xfrm>
+            <a:off x="4731715" y="1872691"/>
+            <a:ext cx="332842" cy="332842"/>
+          </a:xfrm>
+          <a:prstGeom prst="rect">
+            <a:avLst/>
+          </a:prstGeom>
+        </p:spPr>
+      </p:pic>
+      <p:sp>
+        <p:nvSpPr>
+          <p:cNvPr id="12" name="Text 8"/>
+          <p:cNvSpPr/>
+          <p:nvPr/>
+        </p:nvSpPr>
+        <p:spPr>
+          <a:xfrm>
+            <a:off x="4578096" y="2441448"/>
+            <a:ext cx="3087624" cy="411480"/>
+          </a:xfrm>
+          <a:prstGeom prst="rect">
+            <a:avLst/>
+          </a:prstGeom>
+          <a:noFill/>
+          <a:ln/>
+        </p:spPr>
+        <p:txBody>
+          <a:bodyPr wrap="square" lIns="0" tIns="0" rIns="0" bIns="0" rtlCol="0" anchor="t"/>
+          <a:lstStyle/>
+          <a:p>
+            <a:pPr indent="0" marL="0">
+              <a:buNone/>
+            </a:pPr>
+            <a:r>
+              <a:rPr lang="en-US" sz="1450" b="1" dirty="0">
+                <a:solidFill>
+                  <a:srgbClr val="14401A"/>
+                </a:solidFill>
+                <a:latin typeface="Trebuchet MS" pitchFamily="34" charset="0"/>
+                <a:ea typeface="Trebuchet MS" pitchFamily="34" charset="-122"/>
+                <a:cs typeface="Trebuchet MS" pitchFamily="34" charset="-120"/>
+              </a:rPr>
+              <a:t>Scrum · Sprint Backlog</a:t>
+            </a:r>
+            <a:endParaRPr lang="en-US" sz="1450" dirty="0"/>
+          </a:p>
+        </p:txBody>
+      </p:sp>
+      <p:sp>
+        <p:nvSpPr>
+          <p:cNvPr id="13" name="Text 9"/>
+          <p:cNvSpPr/>
+          <p:nvPr/>
+        </p:nvSpPr>
+        <p:spPr>
+          <a:xfrm>
+            <a:off x="4578096" y="2834640"/>
+            <a:ext cx="3087624" cy="594360"/>
+          </a:xfrm>
+          <a:prstGeom prst="rect">
+            <a:avLst/>
+          </a:prstGeom>
+          <a:noFill/>
+          <a:ln/>
+        </p:spPr>
+        <p:txBody>
+          <a:bodyPr wrap="square" lIns="0" tIns="0" rIns="0" bIns="0" rtlCol="0" anchor="t"/>
+          <a:lstStyle/>
+          <a:p>
+            <a:pPr indent="0" marL="0">
+              <a:buNone/>
+            </a:pPr>
+            <a:r>
+              <a:rPr lang="en-US" sz="1200" dirty="0">
+                <a:solidFill>
+                  <a:srgbClr val="55695C"/>
+                </a:solidFill>
+                <a:latin typeface="Calibri" pitchFamily="34" charset="0"/>
+                <a:ea typeface="Calibri" pitchFamily="34" charset="-122"/>
+                <a:cs typeface="Calibri" pitchFamily="34" charset="-120"/>
+              </a:rPr>
+              <a:t>A melhoria vira item da sprint, como qualquer outro. O que não é planejado não acontece.</a:t>
+            </a:r>
+            <a:endParaRPr lang="en-US" sz="1200" dirty="0"/>
+          </a:p>
+        </p:txBody>
+      </p:sp>
+      <p:sp>
+        <p:nvSpPr>
+          <p:cNvPr id="14" name="Shape 10"/>
+          <p:cNvSpPr/>
+          <p:nvPr/>
+        </p:nvSpPr>
+        <p:spPr>
+          <a:xfrm>
+            <a:off x="8095488" y="1481328"/>
+            <a:ext cx="3544824" cy="2011680"/>
+          </a:xfrm>
+          <a:prstGeom prst="roundRect">
+            <a:avLst>
+              <a:gd name="adj" fmla="val 4545"/>
+            </a:avLst>
+          </a:prstGeom>
+          <a:solidFill>
+            <a:srgbClr val="FFFFFF"/>
+          </a:solidFill>
+          <a:ln w="12700">
+            <a:solidFill>
+              <a:srgbClr val="D7E8C8"/>
+            </a:solidFill>
+            <a:prstDash val="solid"/>
+          </a:ln>
+        </p:spPr>
+      </p:sp>
+      <p:sp>
+        <p:nvSpPr>
+          <p:cNvPr id="15" name="Shape 11"/>
+          <p:cNvSpPr/>
+          <p:nvPr/>
+        </p:nvSpPr>
+        <p:spPr>
+          <a:xfrm>
+            <a:off x="8351520" y="1719072"/>
+            <a:ext cx="640080" cy="640080"/>
+          </a:xfrm>
+          <a:prstGeom prst="ellipse">
+            <a:avLst/>
+          </a:prstGeom>
+          <a:solidFill>
+            <a:srgbClr val="EF6C00"/>
+          </a:solidFill>
+          <a:ln/>
+        </p:spPr>
+      </p:sp>
+      <p:pic>
+        <p:nvPicPr>
+          <p:cNvPr id="16" name="Image 2" descr="preencoded.png">    </p:cNvPr>
+          <p:cNvPicPr>
+            <a:picLocks noChangeAspect="1"/>
+          </p:cNvPicPr>
+          <p:nvPr/>
+        </p:nvPicPr>
+        <p:blipFill>
+          <a:blip r:embed="rId3"/>
+          <a:stretch>
+            <a:fillRect/>
+          </a:stretch>
+        </p:blipFill>
+        <p:spPr>
+          <a:xfrm>
+            <a:off x="8505139" y="1872691"/>
+            <a:ext cx="332842" cy="332842"/>
+          </a:xfrm>
+          <a:prstGeom prst="rect">
+            <a:avLst/>
+          </a:prstGeom>
+        </p:spPr>
+      </p:pic>
+      <p:sp>
+        <p:nvSpPr>
+          <p:cNvPr id="17" name="Text 12"/>
+          <p:cNvSpPr/>
+          <p:nvPr/>
+        </p:nvSpPr>
+        <p:spPr>
+          <a:xfrm>
+            <a:off x="8351520" y="2441448"/>
+            <a:ext cx="3087624" cy="411480"/>
+          </a:xfrm>
+          <a:prstGeom prst="rect">
+            <a:avLst/>
+          </a:prstGeom>
+          <a:noFill/>
+          <a:ln/>
+        </p:spPr>
+        <p:txBody>
+          <a:bodyPr wrap="square" lIns="0" tIns="0" rIns="0" bIns="0" rtlCol="0" anchor="t"/>
+          <a:lstStyle/>
+          <a:p>
+            <a:pPr indent="0" marL="0">
+              <a:buNone/>
+            </a:pPr>
+            <a:r>
+              <a:rPr lang="en-US" sz="1450" b="1" dirty="0">
+                <a:solidFill>
+                  <a:srgbClr val="14401A"/>
+                </a:solidFill>
+                <a:latin typeface="Trebuchet MS" pitchFamily="34" charset="0"/>
+                <a:ea typeface="Trebuchet MS" pitchFamily="34" charset="-122"/>
+                <a:cs typeface="Trebuchet MS" pitchFamily="34" charset="-120"/>
+              </a:rPr>
+              <a:t>Kanban · Evoluir junto</a:t>
+            </a:r>
+            <a:endParaRPr lang="en-US" sz="1450" dirty="0"/>
+          </a:p>
+        </p:txBody>
+      </p:sp>
+      <p:sp>
+        <p:nvSpPr>
+          <p:cNvPr id="18" name="Text 13"/>
+          <p:cNvSpPr/>
+          <p:nvPr/>
+        </p:nvSpPr>
+        <p:spPr>
+          <a:xfrm>
+            <a:off x="8351520" y="2834640"/>
+            <a:ext cx="3087624" cy="594360"/>
+          </a:xfrm>
+          <a:prstGeom prst="rect">
+            <a:avLst/>
+          </a:prstGeom>
+          <a:noFill/>
+          <a:ln/>
+        </p:spPr>
+        <p:txBody>
+          <a:bodyPr wrap="square" lIns="0" tIns="0" rIns="0" bIns="0" rtlCol="0" anchor="t"/>
+          <a:lstStyle/>
+          <a:p>
+            <a:pPr indent="0" marL="0">
+              <a:buNone/>
+            </a:pPr>
+            <a:r>
+              <a:rPr lang="en-US" sz="1200" dirty="0">
+                <a:solidFill>
+                  <a:srgbClr val="55695C"/>
+                </a:solidFill>
+                <a:latin typeface="Calibri" pitchFamily="34" charset="0"/>
+                <a:ea typeface="Calibri" pitchFamily="34" charset="-122"/>
+                <a:cs typeface="Calibri" pitchFamily="34" charset="-120"/>
+              </a:rPr>
+              <a:t>"Melhorar de forma colaborativa" é prática do Kanban: ajuste WIP e políticas com dados de fluxo.</a:t>
+            </a:r>
+            <a:endParaRPr lang="en-US" sz="1200" dirty="0"/>
+          </a:p>
+        </p:txBody>
+      </p:sp>
+      <p:sp>
+        <p:nvSpPr>
+          <p:cNvPr id="19" name="Shape 14"/>
+          <p:cNvSpPr/>
+          <p:nvPr/>
+        </p:nvSpPr>
+        <p:spPr>
+          <a:xfrm>
+            <a:off x="548640" y="3675888"/>
+            <a:ext cx="3544824" cy="2011680"/>
+          </a:xfrm>
+          <a:prstGeom prst="roundRect">
+            <a:avLst>
+              <a:gd name="adj" fmla="val 4545"/>
+            </a:avLst>
+          </a:prstGeom>
+          <a:solidFill>
+            <a:srgbClr val="FFFFFF"/>
+          </a:solidFill>
+          <a:ln w="12700">
+            <a:solidFill>
+              <a:srgbClr val="D7E8C8"/>
+            </a:solidFill>
+            <a:prstDash val="solid"/>
+          </a:ln>
+        </p:spPr>
+      </p:sp>
+      <p:sp>
+        <p:nvSpPr>
+          <p:cNvPr id="20" name="Shape 15"/>
+          <p:cNvSpPr/>
+          <p:nvPr/>
+        </p:nvSpPr>
+        <p:spPr>
+          <a:xfrm>
+            <a:off x="804672" y="3913632"/>
+            <a:ext cx="640080" cy="640080"/>
+          </a:xfrm>
+          <a:prstGeom prst="ellipse">
+            <a:avLst/>
+          </a:prstGeom>
+          <a:solidFill>
+            <a:srgbClr val="1565C0"/>
+          </a:solidFill>
+          <a:ln/>
+        </p:spPr>
+      </p:sp>
+      <p:pic>
+        <p:nvPicPr>
+          <p:cNvPr id="21" name="Image 3" descr="preencoded.png">    </p:cNvPr>
+          <p:cNvPicPr>
+            <a:picLocks noChangeAspect="1"/>
+          </p:cNvPicPr>
+          <p:nvPr/>
+        </p:nvPicPr>
+        <p:blipFill>
+          <a:blip r:embed="rId4"/>
+          <a:stretch>
+            <a:fillRect/>
+          </a:stretch>
+        </p:blipFill>
+        <p:spPr>
+          <a:xfrm>
+            <a:off x="958291" y="4067251"/>
+            <a:ext cx="332842" cy="332842"/>
+          </a:xfrm>
+          <a:prstGeom prst="rect">
+            <a:avLst/>
+          </a:prstGeom>
+        </p:spPr>
+      </p:pic>
+      <p:sp>
+        <p:nvSpPr>
+          <p:cNvPr id="22" name="Text 16"/>
+          <p:cNvSpPr/>
+          <p:nvPr/>
+        </p:nvSpPr>
+        <p:spPr>
+          <a:xfrm>
+            <a:off x="804672" y="4636008"/>
+            <a:ext cx="3087624" cy="411480"/>
+          </a:xfrm>
+          <a:prstGeom prst="rect">
+            <a:avLst/>
+          </a:prstGeom>
+          <a:noFill/>
+          <a:ln/>
+        </p:spPr>
+        <p:txBody>
+          <a:bodyPr wrap="square" lIns="0" tIns="0" rIns="0" bIns="0" rtlCol="0" anchor="t"/>
+          <a:lstStyle/>
+          <a:p>
+            <a:pPr indent="0" marL="0">
+              <a:buNone/>
+            </a:pPr>
+            <a:r>
+              <a:rPr lang="en-US" sz="1450" b="1" dirty="0">
+                <a:solidFill>
+                  <a:srgbClr val="14401A"/>
+                </a:solidFill>
+                <a:latin typeface="Trebuchet MS" pitchFamily="34" charset="0"/>
+                <a:ea typeface="Trebuchet MS" pitchFamily="34" charset="-122"/>
+                <a:cs typeface="Trebuchet MS" pitchFamily="34" charset="-120"/>
+              </a:rPr>
+              <a:t>Sonhar · Kickoff</a:t>
+            </a:r>
+            <a:endParaRPr lang="en-US" sz="1450" dirty="0"/>
+          </a:p>
+        </p:txBody>
+      </p:sp>
+      <p:sp>
+        <p:nvSpPr>
+          <p:cNvPr id="23" name="Text 17"/>
+          <p:cNvSpPr/>
+          <p:nvPr/>
+        </p:nvSpPr>
+        <p:spPr>
+          <a:xfrm>
+            <a:off x="804672" y="5029200"/>
+            <a:ext cx="3087624" cy="594360"/>
+          </a:xfrm>
+          <a:prstGeom prst="rect">
+            <a:avLst/>
+          </a:prstGeom>
+          <a:noFill/>
+          <a:ln/>
+        </p:spPr>
+        <p:txBody>
+          <a:bodyPr wrap="square" lIns="0" tIns="0" rIns="0" bIns="0" rtlCol="0" anchor="t"/>
+          <a:lstStyle/>
+          <a:p>
+            <a:pPr indent="0" marL="0">
+              <a:buNone/>
+            </a:pPr>
+            <a:r>
+              <a:rPr lang="en-US" sz="1200" dirty="0">
+                <a:solidFill>
+                  <a:srgbClr val="55695C"/>
+                </a:solidFill>
+                <a:latin typeface="Calibri" pitchFamily="34" charset="0"/>
+                <a:ea typeface="Calibri" pitchFamily="34" charset="-122"/>
+                <a:cs typeface="Calibri" pitchFamily="34" charset="-120"/>
+              </a:rPr>
+              <a:t>Círculo de Sonhos ao abrir o produto ou o épico: cada pessoa diz o que espera. Vira visão e critérios.</a:t>
+            </a:r>
+            <a:endParaRPr lang="en-US" sz="1200" dirty="0"/>
+          </a:p>
+        </p:txBody>
+      </p:sp>
+      <p:sp>
+        <p:nvSpPr>
+          <p:cNvPr id="24" name="Shape 18"/>
+          <p:cNvSpPr/>
+          <p:nvPr/>
+        </p:nvSpPr>
+        <p:spPr>
+          <a:xfrm>
+            <a:off x="4322064" y="3675888"/>
+            <a:ext cx="3544824" cy="2011680"/>
+          </a:xfrm>
+          <a:prstGeom prst="roundRect">
+            <a:avLst>
+              <a:gd name="adj" fmla="val 4545"/>
+            </a:avLst>
+          </a:prstGeom>
+          <a:solidFill>
+            <a:srgbClr val="FFFFFF"/>
+          </a:solidFill>
+          <a:ln w="12700">
+            <a:solidFill>
+              <a:srgbClr val="D7E8C8"/>
+            </a:solidFill>
+            <a:prstDash val="solid"/>
+          </a:ln>
+        </p:spPr>
+      </p:sp>
+      <p:sp>
+        <p:nvSpPr>
+          <p:cNvPr id="25" name="Shape 19"/>
+          <p:cNvSpPr/>
+          <p:nvPr/>
+        </p:nvSpPr>
+        <p:spPr>
+          <a:xfrm>
+            <a:off x="4578096" y="3913632"/>
+            <a:ext cx="640080" cy="640080"/>
+          </a:xfrm>
+          <a:prstGeom prst="ellipse">
+            <a:avLst/>
+          </a:prstGeom>
+          <a:solidFill>
+            <a:srgbClr val="F9A825"/>
+          </a:solidFill>
+          <a:ln/>
+        </p:spPr>
+      </p:sp>
+      <p:pic>
+        <p:nvPicPr>
+          <p:cNvPr id="26" name="Image 4" descr="preencoded.png">    </p:cNvPr>
+          <p:cNvPicPr>
+            <a:picLocks noChangeAspect="1"/>
+          </p:cNvPicPr>
+          <p:nvPr/>
+        </p:nvPicPr>
+        <p:blipFill>
+          <a:blip r:embed="rId5"/>
+          <a:stretch>
+            <a:fillRect/>
+          </a:stretch>
+        </p:blipFill>
+        <p:spPr>
+          <a:xfrm>
+            <a:off x="4731715" y="4067251"/>
+            <a:ext cx="332842" cy="332842"/>
+          </a:xfrm>
+          <a:prstGeom prst="rect">
+            <a:avLst/>
+          </a:prstGeom>
+        </p:spPr>
+      </p:pic>
+      <p:sp>
+        <p:nvSpPr>
+          <p:cNvPr id="27" name="Text 20"/>
+          <p:cNvSpPr/>
+          <p:nvPr/>
+        </p:nvSpPr>
+        <p:spPr>
+          <a:xfrm>
+            <a:off x="4578096" y="4636008"/>
+            <a:ext cx="3087624" cy="411480"/>
+          </a:xfrm>
+          <a:prstGeom prst="rect">
+            <a:avLst/>
+          </a:prstGeom>
+          <a:noFill/>
+          <a:ln/>
+        </p:spPr>
+        <p:txBody>
+          <a:bodyPr wrap="square" lIns="0" tIns="0" rIns="0" bIns="0" rtlCol="0" anchor="t"/>
+          <a:lstStyle/>
+          <a:p>
+            <a:pPr indent="0" marL="0">
+              <a:buNone/>
+            </a:pPr>
+            <a:r>
+              <a:rPr lang="en-US" sz="1450" b="1" dirty="0">
+                <a:solidFill>
+                  <a:srgbClr val="14401A"/>
+                </a:solidFill>
+                <a:latin typeface="Trebuchet MS" pitchFamily="34" charset="0"/>
+                <a:ea typeface="Trebuchet MS" pitchFamily="34" charset="-122"/>
+                <a:cs typeface="Trebuchet MS" pitchFamily="34" charset="-120"/>
+              </a:rPr>
+              <a:t>Híbrido · Scrumban</a:t>
+            </a:r>
+            <a:endParaRPr lang="en-US" sz="1450" dirty="0"/>
+          </a:p>
+        </p:txBody>
+      </p:sp>
+      <p:sp>
+        <p:nvSpPr>
+          <p:cNvPr id="28" name="Text 21"/>
+          <p:cNvSpPr/>
+          <p:nvPr/>
+        </p:nvSpPr>
+        <p:spPr>
+          <a:xfrm>
+            <a:off x="4578096" y="5029200"/>
+            <a:ext cx="3087624" cy="594360"/>
+          </a:xfrm>
+          <a:prstGeom prst="rect">
+            <a:avLst/>
+          </a:prstGeom>
+          <a:noFill/>
+          <a:ln/>
+        </p:spPr>
+        <p:txBody>
+          <a:bodyPr wrap="square" lIns="0" tIns="0" rIns="0" bIns="0" rtlCol="0" anchor="t"/>
+          <a:lstStyle/>
+          <a:p>
+            <a:pPr indent="0" marL="0">
+              <a:buNone/>
+            </a:pPr>
+            <a:r>
+              <a:rPr lang="en-US" sz="1200" dirty="0">
+                <a:solidFill>
+                  <a:srgbClr val="55695C"/>
+                </a:solidFill>
+                <a:latin typeface="Calibri" pitchFamily="34" charset="0"/>
+                <a:ea typeface="Calibri" pitchFamily="34" charset="-122"/>
+                <a:cs typeface="Calibri" pitchFamily="34" charset="-120"/>
+              </a:rPr>
+              <a:t>Realizar = cadência do Scrum + fluxo do Kanban. Kaizen afina o processo; o Sonho segura o rumo.</a:t>
+            </a:r>
+            <a:endParaRPr lang="en-US" sz="1200" dirty="0"/>
+          </a:p>
+        </p:txBody>
+      </p:sp>
+      <p:sp>
+        <p:nvSpPr>
+          <p:cNvPr id="29" name="Shape 22"/>
+          <p:cNvSpPr/>
+          <p:nvPr/>
+        </p:nvSpPr>
+        <p:spPr>
+          <a:xfrm>
+            <a:off x="8095488" y="3675888"/>
+            <a:ext cx="3544824" cy="2011680"/>
+          </a:xfrm>
+          <a:prstGeom prst="roundRect">
+            <a:avLst>
+              <a:gd name="adj" fmla="val 4545"/>
+            </a:avLst>
+          </a:prstGeom>
+          <a:solidFill>
+            <a:srgbClr val="FFFFFF"/>
+          </a:solidFill>
+          <a:ln w="12700">
+            <a:solidFill>
+              <a:srgbClr val="D7E8C8"/>
+            </a:solidFill>
+            <a:prstDash val="solid"/>
+          </a:ln>
+        </p:spPr>
+      </p:sp>
+      <p:sp>
+        <p:nvSpPr>
+          <p:cNvPr id="30" name="Shape 23"/>
+          <p:cNvSpPr/>
+          <p:nvPr/>
+        </p:nvSpPr>
+        <p:spPr>
+          <a:xfrm>
+            <a:off x="8351520" y="3913632"/>
+            <a:ext cx="640080" cy="640080"/>
+          </a:xfrm>
+          <a:prstGeom prst="ellipse">
+            <a:avLst/>
+          </a:prstGeom>
+          <a:solidFill>
+            <a:srgbClr val="7CB342"/>
+          </a:solidFill>
+          <a:ln/>
+        </p:spPr>
+      </p:sp>
+      <p:pic>
+        <p:nvPicPr>
+          <p:cNvPr id="31" name="Image 5" descr="preencoded.png">    </p:cNvPr>
+          <p:cNvPicPr>
+            <a:picLocks noChangeAspect="1"/>
+          </p:cNvPicPr>
+          <p:nvPr/>
+        </p:nvPicPr>
+        <p:blipFill>
+          <a:blip r:embed="rId6"/>
+          <a:stretch>
+            <a:fillRect/>
+          </a:stretch>
+        </p:blipFill>
+        <p:spPr>
+          <a:xfrm>
+            <a:off x="8505139" y="4067251"/>
+            <a:ext cx="332842" cy="332842"/>
+          </a:xfrm>
+          <a:prstGeom prst="rect">
+            <a:avLst/>
+          </a:prstGeom>
+        </p:spPr>
+      </p:pic>
+      <p:sp>
+        <p:nvSpPr>
+          <p:cNvPr id="32" name="Text 24"/>
+          <p:cNvSpPr/>
+          <p:nvPr/>
+        </p:nvSpPr>
+        <p:spPr>
+          <a:xfrm>
+            <a:off x="8351520" y="4636008"/>
+            <a:ext cx="3087624" cy="411480"/>
+          </a:xfrm>
+          <a:prstGeom prst="rect">
+            <a:avLst/>
+          </a:prstGeom>
+          <a:noFill/>
+          <a:ln/>
+        </p:spPr>
+        <p:txBody>
+          <a:bodyPr wrap="square" lIns="0" tIns="0" rIns="0" bIns="0" rtlCol="0" anchor="t"/>
+          <a:lstStyle/>
+          <a:p>
+            <a:pPr indent="0" marL="0">
+              <a:buNone/>
+            </a:pPr>
+            <a:r>
+              <a:rPr lang="en-US" sz="1450" b="1" dirty="0">
+                <a:solidFill>
+                  <a:srgbClr val="14401A"/>
+                </a:solidFill>
+                <a:latin typeface="Trebuchet MS" pitchFamily="34" charset="0"/>
+                <a:ea typeface="Trebuchet MS" pitchFamily="34" charset="-122"/>
+                <a:cs typeface="Trebuchet MS" pitchFamily="34" charset="-120"/>
+              </a:rPr>
+              <a:t>Todos · Celebrar</a:t>
+            </a:r>
+            <a:endParaRPr lang="en-US" sz="1450" dirty="0"/>
+          </a:p>
+        </p:txBody>
+      </p:sp>
+      <p:sp>
+        <p:nvSpPr>
+          <p:cNvPr id="33" name="Text 25"/>
+          <p:cNvSpPr/>
+          <p:nvPr/>
+        </p:nvSpPr>
+        <p:spPr>
+          <a:xfrm>
+            <a:off x="8351520" y="5029200"/>
+            <a:ext cx="3087624" cy="594360"/>
+          </a:xfrm>
+          <a:prstGeom prst="rect">
+            <a:avLst/>
+          </a:prstGeom>
+          <a:noFill/>
+          <a:ln/>
+        </p:spPr>
+        <p:txBody>
+          <a:bodyPr wrap="square" lIns="0" tIns="0" rIns="0" bIns="0" rtlCol="0" anchor="t"/>
+          <a:lstStyle/>
+          <a:p>
+            <a:pPr indent="0" marL="0">
+              <a:buNone/>
+            </a:pPr>
+            <a:r>
+              <a:rPr lang="en-US" sz="1200" dirty="0">
+                <a:solidFill>
+                  <a:srgbClr val="55695C"/>
+                </a:solidFill>
+                <a:latin typeface="Calibri" pitchFamily="34" charset="0"/>
+                <a:ea typeface="Calibri" pitchFamily="34" charset="-122"/>
+                <a:cs typeface="Calibri" pitchFamily="34" charset="-120"/>
+              </a:rPr>
+              <a:t>A Review mostra o resultado; celebrar reconhece as pessoas. Em projeto voluntário, isso é sobrevivência.</a:t>
+            </a:r>
+            <a:endParaRPr lang="en-US" sz="1200" dirty="0"/>
+          </a:p>
+        </p:txBody>
+      </p:sp>
+      <p:sp>
+        <p:nvSpPr>
+          <p:cNvPr id="34" name="Shape 26"/>
+          <p:cNvSpPr/>
+          <p:nvPr/>
+        </p:nvSpPr>
+        <p:spPr>
+          <a:xfrm>
+            <a:off x="0" y="6565392"/>
+            <a:ext cx="12188952" cy="292608"/>
+          </a:xfrm>
+          <a:prstGeom prst="rect">
+            <a:avLst/>
+          </a:prstGeom>
+          <a:solidFill>
+            <a:srgbClr val="14401A"/>
+          </a:solidFill>
+          <a:ln/>
+        </p:spPr>
+      </p:sp>
+      <p:sp>
+        <p:nvSpPr>
+          <p:cNvPr id="35" name="Text 27"/>
+          <p:cNvSpPr/>
+          <p:nvPr/>
+        </p:nvSpPr>
+        <p:spPr>
+          <a:xfrm>
+            <a:off x="365760" y="6565392"/>
+            <a:ext cx="8229600" cy="292608"/>
+          </a:xfrm>
+          <a:prstGeom prst="rect">
+            <a:avLst/>
+          </a:prstGeom>
+          <a:noFill/>
+          <a:ln/>
+        </p:spPr>
+        <p:txBody>
+          <a:bodyPr wrap="square" lIns="0" tIns="0" rIns="0" bIns="0" rtlCol="0" anchor="ctr"/>
+          <a:lstStyle/>
+          <a:p>
+            <a:pPr algn="l" indent="0" marL="0">
+              <a:buNone/>
+            </a:pPr>
+            <a:r>
+              <a:rPr lang="en-US" sz="900" dirty="0">
+                <a:solidFill>
+                  <a:srgbClr val="CFE8C4"/>
+                </a:solidFill>
+                <a:latin typeface="Calibri" pitchFamily="34" charset="0"/>
+                <a:ea typeface="Calibri" pitchFamily="34" charset="-122"/>
+                <a:cs typeface="Calibri" pitchFamily="34" charset="-120"/>
+              </a:rPr>
+              <a:t>Projeto Social Garapuvu 2026 · Módulo 1 · Aula 10 — Scrum e Kanban</a:t>
+            </a:r>
+            <a:endParaRPr lang="en-US" sz="900" dirty="0"/>
+          </a:p>
+        </p:txBody>
+      </p:sp>
+      <p:sp>
+        <p:nvSpPr>
+          <p:cNvPr id="36" name="Text 28"/>
+          <p:cNvSpPr/>
+          <p:nvPr/>
+        </p:nvSpPr>
+        <p:spPr>
+          <a:xfrm>
+            <a:off x="11338560" y="6565392"/>
+            <a:ext cx="502920" cy="292608"/>
+          </a:xfrm>
+          <a:prstGeom prst="rect">
+            <a:avLst/>
+          </a:prstGeom>
+          <a:noFill/>
+          <a:ln/>
+        </p:spPr>
+        <p:txBody>
+          <a:bodyPr wrap="square" lIns="0" tIns="0" rIns="0" bIns="0" rtlCol="0" anchor="ctr"/>
+          <a:lstStyle/>
+          <a:p>
+            <a:pPr algn="r" indent="0" marL="0">
+              <a:buNone/>
+            </a:pPr>
+            <a:r>
+              <a:rPr lang="en-US" sz="900" dirty="0">
+                <a:solidFill>
+                  <a:srgbClr val="CFE8C4"/>
+                </a:solidFill>
+                <a:latin typeface="Calibri" pitchFamily="34" charset="0"/>
+                <a:ea typeface="Calibri" pitchFamily="34" charset="-122"/>
+                <a:cs typeface="Calibri" pitchFamily="34" charset="-120"/>
+              </a:rPr>
+              <a:t>8</a:t>
             </a:r>
             <a:endParaRPr lang="en-US" sz="900" dirty="0"/>
           </a:p>
@@ -3349,7 +5417,7 @@
                 <a:ea typeface="Calibri" pitchFamily="34" charset="-122"/>
                 <a:cs typeface="Calibri" pitchFamily="34" charset="-120"/>
               </a:rPr>
-              <a:t>Fluxo contínuo e quadro</a:t>
+              <a:t>Fluxo contínuo, quadro e WIP</a:t>
             </a:r>
             <a:endParaRPr lang="en-US" sz="1200" dirty="0"/>
           </a:p>
@@ -3459,7 +5527,7 @@
                 <a:ea typeface="Trebuchet MS" pitchFamily="34" charset="-122"/>
                 <a:cs typeface="Trebuchet MS" pitchFamily="34" charset="-120"/>
               </a:rPr>
-              <a:t>WIP e fluxo</a:t>
+              <a:t>Kaizen e Dragon Dreaming</a:t>
             </a:r>
             <a:endParaRPr lang="en-US" sz="1450" dirty="0"/>
           </a:p>
@@ -3498,7 +5566,7 @@
                 <a:ea typeface="Calibri" pitchFamily="34" charset="-122"/>
                 <a:cs typeface="Calibri" pitchFamily="34" charset="-120"/>
               </a:rPr>
-              <a:t>Limitar o trabalho em curso</a:t>
+              <a:t>Melhorar sempre e fechar o ciclo</a:t>
             </a:r>
             <a:endParaRPr lang="en-US" sz="1200" dirty="0"/>
           </a:p>
@@ -8154,7 +10222,7 @@
         </p:nvSpPr>
         <p:spPr>
           <a:xfrm>
-            <a:off x="640080" y="1600200"/>
+            <a:off x="640080" y="1493152"/>
             <a:ext cx="411480" cy="411480"/>
           </a:xfrm>
           <a:prstGeom prst="ellipse">
@@ -8182,7 +10250,7 @@
         </p:blipFill>
         <p:spPr>
           <a:xfrm>
-            <a:off x="738835" y="1698955"/>
+            <a:off x="738835" y="1591907"/>
             <a:ext cx="213970" cy="213970"/>
           </a:xfrm>
           <a:prstGeom prst="rect">
@@ -8198,7 +10266,7 @@
         </p:nvSpPr>
         <p:spPr>
           <a:xfrm>
-            <a:off x="1234440" y="1527048"/>
+            <a:off x="1234440" y="1420000"/>
             <a:ext cx="10332720" cy="566928"/>
           </a:xfrm>
           <a:prstGeom prst="rect">
@@ -8237,7 +10305,7 @@
         </p:nvSpPr>
         <p:spPr>
           <a:xfrm>
-            <a:off x="640080" y="2350008"/>
+            <a:off x="640080" y="2213152"/>
             <a:ext cx="411480" cy="411480"/>
           </a:xfrm>
           <a:prstGeom prst="ellipse">
@@ -8265,7 +10333,7 @@
         </p:blipFill>
         <p:spPr>
           <a:xfrm>
-            <a:off x="738835" y="2448763"/>
+            <a:off x="738835" y="2311907"/>
             <a:ext cx="213970" cy="213970"/>
           </a:xfrm>
           <a:prstGeom prst="rect">
@@ -8281,7 +10349,7 @@
         </p:nvSpPr>
         <p:spPr>
           <a:xfrm>
-            <a:off x="1234440" y="2276856"/>
+            <a:off x="1234440" y="2140000"/>
             <a:ext cx="10332720" cy="566928"/>
           </a:xfrm>
           <a:prstGeom prst="rect">
@@ -8320,7 +10388,7 @@
         </p:nvSpPr>
         <p:spPr>
           <a:xfrm>
-            <a:off x="640080" y="3099816"/>
+            <a:off x="640080" y="2933152"/>
             <a:ext cx="411480" cy="411480"/>
           </a:xfrm>
           <a:prstGeom prst="ellipse">
@@ -8348,7 +10416,7 @@
         </p:blipFill>
         <p:spPr>
           <a:xfrm>
-            <a:off x="738835" y="3198571"/>
+            <a:off x="738835" y="3031907"/>
             <a:ext cx="213970" cy="213970"/>
           </a:xfrm>
           <a:prstGeom prst="rect">
@@ -8364,7 +10432,7 @@
         </p:nvSpPr>
         <p:spPr>
           <a:xfrm>
-            <a:off x="1234440" y="3026664"/>
+            <a:off x="1234440" y="2860000"/>
             <a:ext cx="10332720" cy="566928"/>
           </a:xfrm>
           <a:prstGeom prst="rect">
@@ -8403,7 +10471,7 @@
         </p:nvSpPr>
         <p:spPr>
           <a:xfrm>
-            <a:off x="640080" y="3849624"/>
+            <a:off x="640080" y="3653152"/>
             <a:ext cx="411480" cy="411480"/>
           </a:xfrm>
           <a:prstGeom prst="ellipse">
@@ -8431,7 +10499,7 @@
         </p:blipFill>
         <p:spPr>
           <a:xfrm>
-            <a:off x="738835" y="3948379"/>
+            <a:off x="738835" y="3751907"/>
             <a:ext cx="213970" cy="213970"/>
           </a:xfrm>
           <a:prstGeom prst="rect">
@@ -8447,7 +10515,7 @@
         </p:nvSpPr>
         <p:spPr>
           <a:xfrm>
-            <a:off x="1234440" y="3776472"/>
+            <a:off x="1234440" y="3580000"/>
             <a:ext cx="10332720" cy="566928"/>
           </a:xfrm>
           <a:prstGeom prst="rect">
@@ -8486,7 +10554,7 @@
         </p:nvSpPr>
         <p:spPr>
           <a:xfrm>
-            <a:off x="640080" y="4599432"/>
+            <a:off x="640080" y="4373152"/>
             <a:ext cx="411480" cy="411480"/>
           </a:xfrm>
           <a:prstGeom prst="ellipse">
@@ -8514,7 +10582,7 @@
         </p:blipFill>
         <p:spPr>
           <a:xfrm>
-            <a:off x="738835" y="4698187"/>
+            <a:off x="738835" y="4471907"/>
             <a:ext cx="213970" cy="213970"/>
           </a:xfrm>
           <a:prstGeom prst="rect">
@@ -8530,7 +10598,7 @@
         </p:nvSpPr>
         <p:spPr>
           <a:xfrm>
-            <a:off x="1234440" y="4526280"/>
+            <a:off x="1234440" y="4300000"/>
             <a:ext cx="10332720" cy="566928"/>
           </a:xfrm>
           <a:prstGeom prst="rect">
@@ -8569,7 +10637,7 @@
         </p:nvSpPr>
         <p:spPr>
           <a:xfrm>
-            <a:off x="640080" y="5349240"/>
+            <a:off x="640080" y="5093152"/>
             <a:ext cx="411480" cy="411480"/>
           </a:xfrm>
           <a:prstGeom prst="ellipse">
@@ -8597,7 +10665,7 @@
         </p:blipFill>
         <p:spPr>
           <a:xfrm>
-            <a:off x="738835" y="5447995"/>
+            <a:off x="738835" y="5191907"/>
             <a:ext cx="213970" cy="213970"/>
           </a:xfrm>
           <a:prstGeom prst="rect">
@@ -8613,7 +10681,7 @@
         </p:nvSpPr>
         <p:spPr>
           <a:xfrm>
-            <a:off x="1234440" y="5276088"/>
+            <a:off x="1234440" y="5020000"/>
             <a:ext cx="10332720" cy="566928"/>
           </a:xfrm>
           <a:prstGeom prst="rect">
@@ -8639,6 +10707,89 @@
                 <a:cs typeface="Calibri" pitchFamily="34" charset="-120"/>
               </a:rPr>
               <a:t>Em ambos, qualidade é de todos: testar faz parte de cada item.</a:t>
+            </a:r>
+            <a:endParaRPr lang="en-US" sz="1500" dirty="0"/>
+          </a:p>
+        </p:txBody>
+      </p:sp>
+      <p:sp>
+        <p:nvSpPr>
+          <p:cNvPr id="121" name="Shape 113"/>
+          <p:cNvSpPr/>
+          <p:nvPr/>
+        </p:nvSpPr>
+        <p:spPr>
+          <a:xfrm>
+            <a:off x="640080" y="5813152"/>
+            <a:ext cx="411480" cy="411480"/>
+          </a:xfrm>
+          <a:prstGeom prst="ellipse">
+            <a:avLst/>
+          </a:prstGeom>
+          <a:solidFill>
+            <a:srgbClr val="7CB342"/>
+          </a:solidFill>
+          <a:ln/>
+        </p:spPr>
+      </p:sp>
+      <p:pic>
+        <p:nvPicPr>
+          <p:cNvPr id="122" name="Image 6" descr="preencoded.png">    </p:cNvPr>
+          <p:cNvPicPr>
+            <a:picLocks noChangeAspect="1"/>
+          </p:cNvPicPr>
+          <p:nvPr/>
+        </p:nvPicPr>
+        <p:blipFill>
+          <a:blip r:embed="rId7"/>
+          <a:stretch>
+            <a:fillRect/>
+          </a:stretch>
+        </p:blipFill>
+        <p:spPr>
+          <a:xfrm>
+            <a:off x="738835" y="5911907"/>
+            <a:ext cx="213970" cy="213970"/>
+          </a:xfrm>
+          <a:prstGeom prst="rect">
+            <a:avLst/>
+          </a:prstGeom>
+        </p:spPr>
+      </p:pic>
+      <p:sp>
+        <p:nvSpPr>
+          <p:cNvPr id="123" name="Text 114"/>
+          <p:cNvSpPr/>
+          <p:nvPr/>
+        </p:nvSpPr>
+        <p:spPr>
+          <a:xfrm>
+            <a:off x="1234440" y="5740000"/>
+            <a:ext cx="10332720" cy="566928"/>
+          </a:xfrm>
+          <a:prstGeom prst="rect">
+            <a:avLst/>
+          </a:prstGeom>
+          <a:noFill/>
+          <a:ln/>
+        </p:spPr>
+        <p:txBody>
+          <a:bodyPr wrap="square" lIns="0" tIns="0" rIns="0" bIns="0" rtlCol="0" anchor="ctr"/>
+          <a:lstStyle/>
+          <a:p>
+            <a:pPr indent="0" marL="0">
+              <a:buNone/>
+            </a:pPr>
+            <a:r>
+              <a:rPr lang="en-US" sz="1500" dirty="0">
+                <a:solidFill>
+                  <a:srgbClr val="EAF5E2"/>
+                </a:solidFill>
+                <a:latin typeface="Calibri" pitchFamily="34" charset="0"/>
+                <a:ea typeface="Calibri" pitchFamily="34" charset="-122"/>
+                <a:cs typeface="Calibri" pitchFamily="34" charset="-120"/>
+              </a:rPr>
+              <a:t>Kaizen melhora o processo aos poucos; Dragon Dreaming fecha o ciclo até celebrar.</a:t>
             </a:r>
             <a:endParaRPr lang="en-US" sz="1500" dirty="0"/>
           </a:p>
@@ -8736,7 +10887,7 @@
                 <a:ea typeface="Calibri" pitchFamily="34" charset="-122"/>
                 <a:cs typeface="Calibri" pitchFamily="34" charset="-120"/>
               </a:rPr>
-              <a:t>7</a:t>
+              <a:t>9</a:t>
             </a:r>
             <a:endParaRPr lang="en-US" sz="900" dirty="0"/>
           </a:p>
@@ -9359,13 +11510,13 @@
       </p:sp>
       <p:sp>
         <p:nvSpPr>
-          <p:cNvPr id="20" name="Shape 17"/>
-          <p:cNvSpPr/>
-          <p:nvPr/>
-        </p:nvSpPr>
-        <p:spPr>
-          <a:xfrm>
-            <a:off x="6263640" y="1371600"/>
+          <p:cNvPr id="217" name="Shape 214"/>
+          <p:cNvSpPr/>
+          <p:nvPr/>
+        </p:nvSpPr>
+        <p:spPr>
+          <a:xfrm>
+            <a:off x="502920" y="5577840"/>
             <a:ext cx="5394960" cy="694944"/>
           </a:xfrm>
           <a:prstGeom prst="roundRect">
@@ -9386,86 +11537,86 @@
       </p:sp>
       <p:sp>
         <p:nvSpPr>
-          <p:cNvPr id="21" name="Shape 18"/>
+          <p:cNvPr id="218" name="Shape 215"/>
+          <p:cNvSpPr/>
+          <p:nvPr/>
+        </p:nvSpPr>
+        <p:spPr>
+          <a:xfrm>
+            <a:off x="502920" y="5577840"/>
+            <a:ext cx="82296" cy="694944"/>
+          </a:xfrm>
+          <a:prstGeom prst="rect">
+            <a:avLst/>
+          </a:prstGeom>
+          <a:solidFill>
+            <a:srgbClr val="F9A825"/>
+          </a:solidFill>
+          <a:ln/>
+        </p:spPr>
+      </p:sp>
+      <p:sp>
+        <p:nvSpPr>
+          <p:cNvPr id="219" name="Text 216"/>
+          <p:cNvSpPr/>
+          <p:nvPr/>
+        </p:nvSpPr>
+        <p:spPr>
+          <a:xfrm>
+            <a:off x="704088" y="5596128"/>
+            <a:ext cx="5074920" cy="694944"/>
+          </a:xfrm>
+          <a:prstGeom prst="rect">
+            <a:avLst/>
+          </a:prstGeom>
+          <a:noFill/>
+          <a:ln/>
+        </p:spPr>
+        <p:txBody>
+          <a:bodyPr wrap="square" lIns="50800" tIns="50800" rIns="50800" bIns="50800" rtlCol="0" anchor="ctr"/>
+          <a:lstStyle/>
+          <a:p>
+            <a:pPr indent="0" marL="0">
+              <a:buNone/>
+            </a:pPr>
+            <a:r>
+              <a:rPr lang="en-US" sz="1250" b="1" dirty="0">
+                <a:solidFill>
+                  <a:srgbClr val="2E7D32"/>
+                </a:solidFill>
+                <a:latin typeface="Calibri" pitchFamily="34" charset="0"/>
+                <a:ea typeface="Calibri" pitchFamily="34" charset="-122"/>
+                <a:cs typeface="Calibri" pitchFamily="34" charset="-120"/>
+              </a:rPr>
+              <a:t>Kaizen  </a:t>
+            </a:r>
+            <a:pPr indent="0" marL="0">
+              <a:buNone/>
+            </a:pPr>
+            <a:r>
+              <a:rPr lang="en-US" sz="1250" dirty="0">
+                <a:solidFill>
+                  <a:srgbClr val="1B3A1B"/>
+                </a:solidFill>
+                <a:latin typeface="Calibri" pitchFamily="34" charset="0"/>
+                <a:ea typeface="Calibri" pitchFamily="34" charset="-122"/>
+                <a:cs typeface="Calibri" pitchFamily="34" charset="-120"/>
+              </a:rPr>
+              <a:t>— Melhoria contínua em passos pequenos</a:t>
+            </a:r>
+            <a:endParaRPr lang="en-US" sz="1250" dirty="0"/>
+          </a:p>
+        </p:txBody>
+      </p:sp>
+      <p:sp>
+        <p:nvSpPr>
+          <p:cNvPr id="20" name="Shape 17"/>
           <p:cNvSpPr/>
           <p:nvPr/>
         </p:nvSpPr>
         <p:spPr>
           <a:xfrm>
             <a:off x="6263640" y="1371600"/>
-            <a:ext cx="82296" cy="694944"/>
-          </a:xfrm>
-          <a:prstGeom prst="rect">
-            <a:avLst/>
-          </a:prstGeom>
-          <a:solidFill>
-            <a:srgbClr val="F9A825"/>
-          </a:solidFill>
-          <a:ln/>
-        </p:spPr>
-      </p:sp>
-      <p:sp>
-        <p:nvSpPr>
-          <p:cNvPr id="22" name="Text 19"/>
-          <p:cNvSpPr/>
-          <p:nvPr/>
-        </p:nvSpPr>
-        <p:spPr>
-          <a:xfrm>
-            <a:off x="6464808" y="1389888"/>
-            <a:ext cx="5074920" cy="694944"/>
-          </a:xfrm>
-          <a:prstGeom prst="rect">
-            <a:avLst/>
-          </a:prstGeom>
-          <a:noFill/>
-          <a:ln/>
-        </p:spPr>
-        <p:txBody>
-          <a:bodyPr wrap="square" lIns="50800" tIns="50800" rIns="50800" bIns="50800" rtlCol="0" anchor="ctr"/>
-          <a:lstStyle/>
-          <a:p>
-            <a:pPr indent="0" marL="0">
-              <a:buNone/>
-            </a:pPr>
-            <a:r>
-              <a:rPr lang="en-US" sz="1250" b="1" dirty="0">
-                <a:solidFill>
-                  <a:srgbClr val="2E7D32"/>
-                </a:solidFill>
-                <a:latin typeface="Calibri" pitchFamily="34" charset="0"/>
-                <a:ea typeface="Calibri" pitchFamily="34" charset="-122"/>
-                <a:cs typeface="Calibri" pitchFamily="34" charset="-120"/>
-              </a:rPr>
-              <a:t>Incremento  </a:t>
-            </a:r>
-            <a:pPr indent="0" marL="0">
-              <a:buNone/>
-            </a:pPr>
-            <a:r>
-              <a:rPr lang="en-US" sz="1250" dirty="0">
-                <a:solidFill>
-                  <a:srgbClr val="1B3A1B"/>
-                </a:solidFill>
-                <a:latin typeface="Calibri" pitchFamily="34" charset="0"/>
-                <a:ea typeface="Calibri" pitchFamily="34" charset="-122"/>
-                <a:cs typeface="Calibri" pitchFamily="34" charset="-120"/>
-              </a:rPr>
-              <a:t>— Resultado pronto entregue na sprint</a:t>
-            </a:r>
-            <a:endParaRPr lang="en-US" sz="1250" dirty="0"/>
-          </a:p>
-        </p:txBody>
-      </p:sp>
-      <p:sp>
-        <p:nvSpPr>
-          <p:cNvPr id="23" name="Shape 20"/>
-          <p:cNvSpPr/>
-          <p:nvPr/>
-        </p:nvSpPr>
-        <p:spPr>
-          <a:xfrm>
-            <a:off x="6263640" y="2212848"/>
             <a:ext cx="5394960" cy="694944"/>
           </a:xfrm>
           <a:prstGeom prst="roundRect">
@@ -9486,86 +11637,86 @@
       </p:sp>
       <p:sp>
         <p:nvSpPr>
-          <p:cNvPr id="24" name="Shape 21"/>
+          <p:cNvPr id="21" name="Shape 18"/>
+          <p:cNvSpPr/>
+          <p:nvPr/>
+        </p:nvSpPr>
+        <p:spPr>
+          <a:xfrm>
+            <a:off x="6263640" y="1371600"/>
+            <a:ext cx="82296" cy="694944"/>
+          </a:xfrm>
+          <a:prstGeom prst="rect">
+            <a:avLst/>
+          </a:prstGeom>
+          <a:solidFill>
+            <a:srgbClr val="F9A825"/>
+          </a:solidFill>
+          <a:ln/>
+        </p:spPr>
+      </p:sp>
+      <p:sp>
+        <p:nvSpPr>
+          <p:cNvPr id="22" name="Text 19"/>
+          <p:cNvSpPr/>
+          <p:nvPr/>
+        </p:nvSpPr>
+        <p:spPr>
+          <a:xfrm>
+            <a:off x="6464808" y="1389888"/>
+            <a:ext cx="5074920" cy="694944"/>
+          </a:xfrm>
+          <a:prstGeom prst="rect">
+            <a:avLst/>
+          </a:prstGeom>
+          <a:noFill/>
+          <a:ln/>
+        </p:spPr>
+        <p:txBody>
+          <a:bodyPr wrap="square" lIns="50800" tIns="50800" rIns="50800" bIns="50800" rtlCol="0" anchor="ctr"/>
+          <a:lstStyle/>
+          <a:p>
+            <a:pPr indent="0" marL="0">
+              <a:buNone/>
+            </a:pPr>
+            <a:r>
+              <a:rPr lang="en-US" sz="1250" b="1" dirty="0">
+                <a:solidFill>
+                  <a:srgbClr val="2E7D32"/>
+                </a:solidFill>
+                <a:latin typeface="Calibri" pitchFamily="34" charset="0"/>
+                <a:ea typeface="Calibri" pitchFamily="34" charset="-122"/>
+                <a:cs typeface="Calibri" pitchFamily="34" charset="-120"/>
+              </a:rPr>
+              <a:t>Incremento  </a:t>
+            </a:r>
+            <a:pPr indent="0" marL="0">
+              <a:buNone/>
+            </a:pPr>
+            <a:r>
+              <a:rPr lang="en-US" sz="1250" dirty="0">
+                <a:solidFill>
+                  <a:srgbClr val="1B3A1B"/>
+                </a:solidFill>
+                <a:latin typeface="Calibri" pitchFamily="34" charset="0"/>
+                <a:ea typeface="Calibri" pitchFamily="34" charset="-122"/>
+                <a:cs typeface="Calibri" pitchFamily="34" charset="-120"/>
+              </a:rPr>
+              <a:t>— Resultado pronto entregue na sprint</a:t>
+            </a:r>
+            <a:endParaRPr lang="en-US" sz="1250" dirty="0"/>
+          </a:p>
+        </p:txBody>
+      </p:sp>
+      <p:sp>
+        <p:nvSpPr>
+          <p:cNvPr id="23" name="Shape 20"/>
           <p:cNvSpPr/>
           <p:nvPr/>
         </p:nvSpPr>
         <p:spPr>
           <a:xfrm>
             <a:off x="6263640" y="2212848"/>
-            <a:ext cx="82296" cy="694944"/>
-          </a:xfrm>
-          <a:prstGeom prst="rect">
-            <a:avLst/>
-          </a:prstGeom>
-          <a:solidFill>
-            <a:srgbClr val="F9A825"/>
-          </a:solidFill>
-          <a:ln/>
-        </p:spPr>
-      </p:sp>
-      <p:sp>
-        <p:nvSpPr>
-          <p:cNvPr id="25" name="Text 22"/>
-          <p:cNvSpPr/>
-          <p:nvPr/>
-        </p:nvSpPr>
-        <p:spPr>
-          <a:xfrm>
-            <a:off x="6464808" y="2231136"/>
-            <a:ext cx="5074920" cy="694944"/>
-          </a:xfrm>
-          <a:prstGeom prst="rect">
-            <a:avLst/>
-          </a:prstGeom>
-          <a:noFill/>
-          <a:ln/>
-        </p:spPr>
-        <p:txBody>
-          <a:bodyPr wrap="square" lIns="50800" tIns="50800" rIns="50800" bIns="50800" rtlCol="0" anchor="ctr"/>
-          <a:lstStyle/>
-          <a:p>
-            <a:pPr indent="0" marL="0">
-              <a:buNone/>
-            </a:pPr>
-            <a:r>
-              <a:rPr lang="en-US" sz="1250" b="1" dirty="0">
-                <a:solidFill>
-                  <a:srgbClr val="2E7D32"/>
-                </a:solidFill>
-                <a:latin typeface="Calibri" pitchFamily="34" charset="0"/>
-                <a:ea typeface="Calibri" pitchFamily="34" charset="-122"/>
-                <a:cs typeface="Calibri" pitchFamily="34" charset="-120"/>
-              </a:rPr>
-              <a:t>Daily  </a:t>
-            </a:r>
-            <a:pPr indent="0" marL="0">
-              <a:buNone/>
-            </a:pPr>
-            <a:r>
-              <a:rPr lang="en-US" sz="1250" dirty="0">
-                <a:solidFill>
-                  <a:srgbClr val="1B3A1B"/>
-                </a:solidFill>
-                <a:latin typeface="Calibri" pitchFamily="34" charset="0"/>
-                <a:ea typeface="Calibri" pitchFamily="34" charset="-122"/>
-                <a:cs typeface="Calibri" pitchFamily="34" charset="-120"/>
-              </a:rPr>
-              <a:t>— Reunião diária rápida de sincronização</a:t>
-            </a:r>
-            <a:endParaRPr lang="en-US" sz="1250" dirty="0"/>
-          </a:p>
-        </p:txBody>
-      </p:sp>
-      <p:sp>
-        <p:nvSpPr>
-          <p:cNvPr id="26" name="Shape 23"/>
-          <p:cNvSpPr/>
-          <p:nvPr/>
-        </p:nvSpPr>
-        <p:spPr>
-          <a:xfrm>
-            <a:off x="6263640" y="3054096"/>
             <a:ext cx="5394960" cy="694944"/>
           </a:xfrm>
           <a:prstGeom prst="roundRect">
@@ -9586,86 +11737,86 @@
       </p:sp>
       <p:sp>
         <p:nvSpPr>
-          <p:cNvPr id="27" name="Shape 24"/>
+          <p:cNvPr id="24" name="Shape 21"/>
+          <p:cNvSpPr/>
+          <p:nvPr/>
+        </p:nvSpPr>
+        <p:spPr>
+          <a:xfrm>
+            <a:off x="6263640" y="2212848"/>
+            <a:ext cx="82296" cy="694944"/>
+          </a:xfrm>
+          <a:prstGeom prst="rect">
+            <a:avLst/>
+          </a:prstGeom>
+          <a:solidFill>
+            <a:srgbClr val="F9A825"/>
+          </a:solidFill>
+          <a:ln/>
+        </p:spPr>
+      </p:sp>
+      <p:sp>
+        <p:nvSpPr>
+          <p:cNvPr id="25" name="Text 22"/>
+          <p:cNvSpPr/>
+          <p:nvPr/>
+        </p:nvSpPr>
+        <p:spPr>
+          <a:xfrm>
+            <a:off x="6464808" y="2231136"/>
+            <a:ext cx="5074920" cy="694944"/>
+          </a:xfrm>
+          <a:prstGeom prst="rect">
+            <a:avLst/>
+          </a:prstGeom>
+          <a:noFill/>
+          <a:ln/>
+        </p:spPr>
+        <p:txBody>
+          <a:bodyPr wrap="square" lIns="50800" tIns="50800" rIns="50800" bIns="50800" rtlCol="0" anchor="ctr"/>
+          <a:lstStyle/>
+          <a:p>
+            <a:pPr indent="0" marL="0">
+              <a:buNone/>
+            </a:pPr>
+            <a:r>
+              <a:rPr lang="en-US" sz="1250" b="1" dirty="0">
+                <a:solidFill>
+                  <a:srgbClr val="2E7D32"/>
+                </a:solidFill>
+                <a:latin typeface="Calibri" pitchFamily="34" charset="0"/>
+                <a:ea typeface="Calibri" pitchFamily="34" charset="-122"/>
+                <a:cs typeface="Calibri" pitchFamily="34" charset="-120"/>
+              </a:rPr>
+              <a:t>Daily  </a:t>
+            </a:r>
+            <a:pPr indent="0" marL="0">
+              <a:buNone/>
+            </a:pPr>
+            <a:r>
+              <a:rPr lang="en-US" sz="1250" dirty="0">
+                <a:solidFill>
+                  <a:srgbClr val="1B3A1B"/>
+                </a:solidFill>
+                <a:latin typeface="Calibri" pitchFamily="34" charset="0"/>
+                <a:ea typeface="Calibri" pitchFamily="34" charset="-122"/>
+                <a:cs typeface="Calibri" pitchFamily="34" charset="-120"/>
+              </a:rPr>
+              <a:t>— Reunião diária rápida de sincronização</a:t>
+            </a:r>
+            <a:endParaRPr lang="en-US" sz="1250" dirty="0"/>
+          </a:p>
+        </p:txBody>
+      </p:sp>
+      <p:sp>
+        <p:nvSpPr>
+          <p:cNvPr id="26" name="Shape 23"/>
           <p:cNvSpPr/>
           <p:nvPr/>
         </p:nvSpPr>
         <p:spPr>
           <a:xfrm>
             <a:off x="6263640" y="3054096"/>
-            <a:ext cx="82296" cy="694944"/>
-          </a:xfrm>
-          <a:prstGeom prst="rect">
-            <a:avLst/>
-          </a:prstGeom>
-          <a:solidFill>
-            <a:srgbClr val="F9A825"/>
-          </a:solidFill>
-          <a:ln/>
-        </p:spPr>
-      </p:sp>
-      <p:sp>
-        <p:nvSpPr>
-          <p:cNvPr id="28" name="Text 25"/>
-          <p:cNvSpPr/>
-          <p:nvPr/>
-        </p:nvSpPr>
-        <p:spPr>
-          <a:xfrm>
-            <a:off x="6464808" y="3072384"/>
-            <a:ext cx="5074920" cy="694944"/>
-          </a:xfrm>
-          <a:prstGeom prst="rect">
-            <a:avLst/>
-          </a:prstGeom>
-          <a:noFill/>
-          <a:ln/>
-        </p:spPr>
-        <p:txBody>
-          <a:bodyPr wrap="square" lIns="50800" tIns="50800" rIns="50800" bIns="50800" rtlCol="0" anchor="ctr"/>
-          <a:lstStyle/>
-          <a:p>
-            <a:pPr indent="0" marL="0">
-              <a:buNone/>
-            </a:pPr>
-            <a:r>
-              <a:rPr lang="en-US" sz="1250" b="1" dirty="0">
-                <a:solidFill>
-                  <a:srgbClr val="2E7D32"/>
-                </a:solidFill>
-                <a:latin typeface="Calibri" pitchFamily="34" charset="0"/>
-                <a:ea typeface="Calibri" pitchFamily="34" charset="-122"/>
-                <a:cs typeface="Calibri" pitchFamily="34" charset="-120"/>
-              </a:rPr>
-              <a:t>Retrospectiva  </a:t>
-            </a:r>
-            <a:pPr indent="0" marL="0">
-              <a:buNone/>
-            </a:pPr>
-            <a:r>
-              <a:rPr lang="en-US" sz="1250" dirty="0">
-                <a:solidFill>
-                  <a:srgbClr val="1B3A1B"/>
-                </a:solidFill>
-                <a:latin typeface="Calibri" pitchFamily="34" charset="0"/>
-                <a:ea typeface="Calibri" pitchFamily="34" charset="-122"/>
-                <a:cs typeface="Calibri" pitchFamily="34" charset="-120"/>
-              </a:rPr>
-              <a:t>— Reunião para melhorar o processo</a:t>
-            </a:r>
-            <a:endParaRPr lang="en-US" sz="1250" dirty="0"/>
-          </a:p>
-        </p:txBody>
-      </p:sp>
-      <p:sp>
-        <p:nvSpPr>
-          <p:cNvPr id="29" name="Shape 26"/>
-          <p:cNvSpPr/>
-          <p:nvPr/>
-        </p:nvSpPr>
-        <p:spPr>
-          <a:xfrm>
-            <a:off x="6263640" y="3895344"/>
             <a:ext cx="5394960" cy="694944"/>
           </a:xfrm>
           <a:prstGeom prst="roundRect">
@@ -9686,86 +11837,86 @@
       </p:sp>
       <p:sp>
         <p:nvSpPr>
-          <p:cNvPr id="30" name="Shape 27"/>
+          <p:cNvPr id="27" name="Shape 24"/>
+          <p:cNvSpPr/>
+          <p:nvPr/>
+        </p:nvSpPr>
+        <p:spPr>
+          <a:xfrm>
+            <a:off x="6263640" y="3054096"/>
+            <a:ext cx="82296" cy="694944"/>
+          </a:xfrm>
+          <a:prstGeom prst="rect">
+            <a:avLst/>
+          </a:prstGeom>
+          <a:solidFill>
+            <a:srgbClr val="F9A825"/>
+          </a:solidFill>
+          <a:ln/>
+        </p:spPr>
+      </p:sp>
+      <p:sp>
+        <p:nvSpPr>
+          <p:cNvPr id="28" name="Text 25"/>
+          <p:cNvSpPr/>
+          <p:nvPr/>
+        </p:nvSpPr>
+        <p:spPr>
+          <a:xfrm>
+            <a:off x="6464808" y="3072384"/>
+            <a:ext cx="5074920" cy="694944"/>
+          </a:xfrm>
+          <a:prstGeom prst="rect">
+            <a:avLst/>
+          </a:prstGeom>
+          <a:noFill/>
+          <a:ln/>
+        </p:spPr>
+        <p:txBody>
+          <a:bodyPr wrap="square" lIns="50800" tIns="50800" rIns="50800" bIns="50800" rtlCol="0" anchor="ctr"/>
+          <a:lstStyle/>
+          <a:p>
+            <a:pPr indent="0" marL="0">
+              <a:buNone/>
+            </a:pPr>
+            <a:r>
+              <a:rPr lang="en-US" sz="1250" b="1" dirty="0">
+                <a:solidFill>
+                  <a:srgbClr val="2E7D32"/>
+                </a:solidFill>
+                <a:latin typeface="Calibri" pitchFamily="34" charset="0"/>
+                <a:ea typeface="Calibri" pitchFamily="34" charset="-122"/>
+                <a:cs typeface="Calibri" pitchFamily="34" charset="-120"/>
+              </a:rPr>
+              <a:t>Retrospectiva  </a:t>
+            </a:r>
+            <a:pPr indent="0" marL="0">
+              <a:buNone/>
+            </a:pPr>
+            <a:r>
+              <a:rPr lang="en-US" sz="1250" dirty="0">
+                <a:solidFill>
+                  <a:srgbClr val="1B3A1B"/>
+                </a:solidFill>
+                <a:latin typeface="Calibri" pitchFamily="34" charset="0"/>
+                <a:ea typeface="Calibri" pitchFamily="34" charset="-122"/>
+                <a:cs typeface="Calibri" pitchFamily="34" charset="-120"/>
+              </a:rPr>
+              <a:t>— Reunião para melhorar o processo</a:t>
+            </a:r>
+            <a:endParaRPr lang="en-US" sz="1250" dirty="0"/>
+          </a:p>
+        </p:txBody>
+      </p:sp>
+      <p:sp>
+        <p:nvSpPr>
+          <p:cNvPr id="29" name="Shape 26"/>
           <p:cNvSpPr/>
           <p:nvPr/>
         </p:nvSpPr>
         <p:spPr>
           <a:xfrm>
             <a:off x="6263640" y="3895344"/>
-            <a:ext cx="82296" cy="694944"/>
-          </a:xfrm>
-          <a:prstGeom prst="rect">
-            <a:avLst/>
-          </a:prstGeom>
-          <a:solidFill>
-            <a:srgbClr val="F9A825"/>
-          </a:solidFill>
-          <a:ln/>
-        </p:spPr>
-      </p:sp>
-      <p:sp>
-        <p:nvSpPr>
-          <p:cNvPr id="31" name="Text 28"/>
-          <p:cNvSpPr/>
-          <p:nvPr/>
-        </p:nvSpPr>
-        <p:spPr>
-          <a:xfrm>
-            <a:off x="6464808" y="3913632"/>
-            <a:ext cx="5074920" cy="694944"/>
-          </a:xfrm>
-          <a:prstGeom prst="rect">
-            <a:avLst/>
-          </a:prstGeom>
-          <a:noFill/>
-          <a:ln/>
-        </p:spPr>
-        <p:txBody>
-          <a:bodyPr wrap="square" lIns="50800" tIns="50800" rIns="50800" bIns="50800" rtlCol="0" anchor="ctr"/>
-          <a:lstStyle/>
-          <a:p>
-            <a:pPr indent="0" marL="0">
-              <a:buNone/>
-            </a:pPr>
-            <a:r>
-              <a:rPr lang="en-US" sz="1250" b="1" dirty="0">
-                <a:solidFill>
-                  <a:srgbClr val="2E7D32"/>
-                </a:solidFill>
-                <a:latin typeface="Calibri" pitchFamily="34" charset="0"/>
-                <a:ea typeface="Calibri" pitchFamily="34" charset="-122"/>
-                <a:cs typeface="Calibri" pitchFamily="34" charset="-120"/>
-              </a:rPr>
-              <a:t>Kanban  </a:t>
-            </a:r>
-            <a:pPr indent="0" marL="0">
-              <a:buNone/>
-            </a:pPr>
-            <a:r>
-              <a:rPr lang="en-US" sz="1250" dirty="0">
-                <a:solidFill>
-                  <a:srgbClr val="1B3A1B"/>
-                </a:solidFill>
-                <a:latin typeface="Calibri" pitchFamily="34" charset="0"/>
-                <a:ea typeface="Calibri" pitchFamily="34" charset="-122"/>
-                <a:cs typeface="Calibri" pitchFamily="34" charset="-120"/>
-              </a:rPr>
-              <a:t>— Método ágil de fluxo contínuo com quadro visual</a:t>
-            </a:r>
-            <a:endParaRPr lang="en-US" sz="1250" dirty="0"/>
-          </a:p>
-        </p:txBody>
-      </p:sp>
-      <p:sp>
-        <p:nvSpPr>
-          <p:cNvPr id="32" name="Shape 29"/>
-          <p:cNvSpPr/>
-          <p:nvPr/>
-        </p:nvSpPr>
-        <p:spPr>
-          <a:xfrm>
-            <a:off x="6263640" y="4736592"/>
             <a:ext cx="5394960" cy="694944"/>
           </a:xfrm>
           <a:prstGeom prst="roundRect">
@@ -9786,6 +11937,106 @@
       </p:sp>
       <p:sp>
         <p:nvSpPr>
+          <p:cNvPr id="30" name="Shape 27"/>
+          <p:cNvSpPr/>
+          <p:nvPr/>
+        </p:nvSpPr>
+        <p:spPr>
+          <a:xfrm>
+            <a:off x="6263640" y="3895344"/>
+            <a:ext cx="82296" cy="694944"/>
+          </a:xfrm>
+          <a:prstGeom prst="rect">
+            <a:avLst/>
+          </a:prstGeom>
+          <a:solidFill>
+            <a:srgbClr val="F9A825"/>
+          </a:solidFill>
+          <a:ln/>
+        </p:spPr>
+      </p:sp>
+      <p:sp>
+        <p:nvSpPr>
+          <p:cNvPr id="31" name="Text 28"/>
+          <p:cNvSpPr/>
+          <p:nvPr/>
+        </p:nvSpPr>
+        <p:spPr>
+          <a:xfrm>
+            <a:off x="6464808" y="3913632"/>
+            <a:ext cx="5074920" cy="694944"/>
+          </a:xfrm>
+          <a:prstGeom prst="rect">
+            <a:avLst/>
+          </a:prstGeom>
+          <a:noFill/>
+          <a:ln/>
+        </p:spPr>
+        <p:txBody>
+          <a:bodyPr wrap="square" lIns="50800" tIns="50800" rIns="50800" bIns="50800" rtlCol="0" anchor="ctr"/>
+          <a:lstStyle/>
+          <a:p>
+            <a:pPr indent="0" marL="0">
+              <a:buNone/>
+            </a:pPr>
+            <a:r>
+              <a:rPr lang="en-US" sz="1250" b="1" dirty="0">
+                <a:solidFill>
+                  <a:srgbClr val="2E7D32"/>
+                </a:solidFill>
+                <a:latin typeface="Calibri" pitchFamily="34" charset="0"/>
+                <a:ea typeface="Calibri" pitchFamily="34" charset="-122"/>
+                <a:cs typeface="Calibri" pitchFamily="34" charset="-120"/>
+              </a:rPr>
+              <a:t>Kanban  </a:t>
+            </a:r>
+            <a:pPr indent="0" marL="0">
+              <a:buNone/>
+            </a:pPr>
+            <a:r>
+              <a:rPr lang="en-US" sz="1250" dirty="0">
+                <a:solidFill>
+                  <a:srgbClr val="1B3A1B"/>
+                </a:solidFill>
+                <a:latin typeface="Calibri" pitchFamily="34" charset="0"/>
+                <a:ea typeface="Calibri" pitchFamily="34" charset="-122"/>
+                <a:cs typeface="Calibri" pitchFamily="34" charset="-120"/>
+              </a:rPr>
+              <a:t>— Método ágil de fluxo contínuo com quadro visual</a:t>
+            </a:r>
+            <a:endParaRPr lang="en-US" sz="1250" dirty="0"/>
+          </a:p>
+        </p:txBody>
+      </p:sp>
+      <p:sp>
+        <p:nvSpPr>
+          <p:cNvPr id="32" name="Shape 29"/>
+          <p:cNvSpPr/>
+          <p:nvPr/>
+        </p:nvSpPr>
+        <p:spPr>
+          <a:xfrm>
+            <a:off x="6263640" y="4736592"/>
+            <a:ext cx="5394960" cy="694944"/>
+          </a:xfrm>
+          <a:prstGeom prst="roundRect">
+            <a:avLst>
+              <a:gd name="adj" fmla="val 13158"/>
+            </a:avLst>
+          </a:prstGeom>
+          <a:solidFill>
+            <a:srgbClr val="FFFFFF"/>
+          </a:solidFill>
+          <a:ln w="12700">
+            <a:solidFill>
+              <a:srgbClr val="D7E8C8"/>
+            </a:solidFill>
+            <a:prstDash val="solid"/>
+          </a:ln>
+        </p:spPr>
+      </p:sp>
+      <p:sp>
+        <p:nvSpPr>
           <p:cNvPr id="33" name="Shape 30"/>
           <p:cNvSpPr/>
           <p:nvPr/>
@@ -9852,6 +12103,106 @@
                 <a:cs typeface="Calibri" pitchFamily="34" charset="-120"/>
               </a:rPr>
               <a:t>— Work In Progress — trabalho em andamento (limitado)</a:t>
+            </a:r>
+            <a:endParaRPr lang="en-US" sz="1250" dirty="0"/>
+          </a:p>
+        </p:txBody>
+      </p:sp>
+      <p:sp>
+        <p:nvSpPr>
+          <p:cNvPr id="332" name="Shape 329"/>
+          <p:cNvSpPr/>
+          <p:nvPr/>
+        </p:nvSpPr>
+        <p:spPr>
+          <a:xfrm>
+            <a:off x="6263640" y="5577840"/>
+            <a:ext cx="5394960" cy="694944"/>
+          </a:xfrm>
+          <a:prstGeom prst="roundRect">
+            <a:avLst>
+              <a:gd name="adj" fmla="val 13158"/>
+            </a:avLst>
+          </a:prstGeom>
+          <a:solidFill>
+            <a:srgbClr val="FFFFFF"/>
+          </a:solidFill>
+          <a:ln w="12700">
+            <a:solidFill>
+              <a:srgbClr val="D7E8C8"/>
+            </a:solidFill>
+            <a:prstDash val="solid"/>
+          </a:ln>
+        </p:spPr>
+      </p:sp>
+      <p:sp>
+        <p:nvSpPr>
+          <p:cNvPr id="333" name="Shape 330"/>
+          <p:cNvSpPr/>
+          <p:nvPr/>
+        </p:nvSpPr>
+        <p:spPr>
+          <a:xfrm>
+            <a:off x="6263640" y="5577840"/>
+            <a:ext cx="82296" cy="694944"/>
+          </a:xfrm>
+          <a:prstGeom prst="rect">
+            <a:avLst/>
+          </a:prstGeom>
+          <a:solidFill>
+            <a:srgbClr val="F9A825"/>
+          </a:solidFill>
+          <a:ln/>
+        </p:spPr>
+      </p:sp>
+      <p:sp>
+        <p:nvSpPr>
+          <p:cNvPr id="334" name="Text 331"/>
+          <p:cNvSpPr/>
+          <p:nvPr/>
+        </p:nvSpPr>
+        <p:spPr>
+          <a:xfrm>
+            <a:off x="6464808" y="5596128"/>
+            <a:ext cx="5074920" cy="694944"/>
+          </a:xfrm>
+          <a:prstGeom prst="rect">
+            <a:avLst/>
+          </a:prstGeom>
+          <a:noFill/>
+          <a:ln/>
+        </p:spPr>
+        <p:txBody>
+          <a:bodyPr wrap="square" lIns="50800" tIns="50800" rIns="50800" bIns="50800" rtlCol="0" anchor="ctr"/>
+          <a:lstStyle/>
+          <a:p>
+            <a:pPr indent="0" marL="0">
+              <a:buNone/>
+            </a:pPr>
+            <a:r>
+              <a:rPr lang="en-US" sz="1250" b="1" dirty="0">
+                <a:solidFill>
+                  <a:srgbClr val="2E7D32"/>
+                </a:solidFill>
+                <a:latin typeface="Calibri" pitchFamily="34" charset="0"/>
+                <a:ea typeface="Calibri" pitchFamily="34" charset="-122"/>
+                <a:cs typeface="Calibri" pitchFamily="34" charset="-120"/>
+              </a:rPr>
+              <a:t>Dragon Dreaming  </a:t>
+            </a:r>
+            <a:pPr indent="0" marL="0">
+              <a:buNone/>
+            </a:pPr>
+            <a:r>
+              <a:rPr lang="en-US" sz="1250" dirty="0">
+                <a:solidFill>
+                  <a:srgbClr val="1B3A1B"/>
+                </a:solidFill>
+                <a:latin typeface="Calibri" pitchFamily="34" charset="0"/>
+                <a:ea typeface="Calibri" pitchFamily="34" charset="-122"/>
+                <a:cs typeface="Calibri" pitchFamily="34" charset="-120"/>
+              </a:rPr>
+              <a:t>— Sonhar, Planejar, Realizar e Celebrar</a:t>
             </a:r>
             <a:endParaRPr lang="en-US" sz="1250" dirty="0"/>
           </a:p>

</xml_diff>